<commit_message>
Fix line overlap in all bullet cards
Textbox height was lh+0.06 but cur_y only advanced by lh — each line's
box overlapped the next by 0.06". Now both the textbox height and the
y-advance use the same value (lh+0.06), and content_h() accounts for
the extra 0.06 per line so card boxes remain correctly sized.

Co-Authored-By: Claude Sonnet 4.6 <noreply@anthropic.com>
</commit_message>
<xml_diff>
--- a/docs/Pellet_Burner_Components.pptx
+++ b/docs/Pellet_Burner_Components.pptx
@@ -6074,7 +6074,7 @@
         <p:spPr>
           <a:xfrm>
             <a:off x="274320" y="749808"/>
-            <a:ext cx="5029200" cy="3758183"/>
+            <a:ext cx="5029200" cy="4471415"/>
           </a:xfrm>
           <a:prstGeom prst="rect">
             <a:avLst/>
@@ -6150,7 +6150,7 @@
         </p:nvSpPr>
         <p:spPr>
           <a:xfrm>
-            <a:off x="438912" y="1125473"/>
+            <a:off x="438912" y="1180337"/>
             <a:ext cx="4700016" cy="321564"/>
           </a:xfrm>
           <a:prstGeom prst="rect">
@@ -6184,7 +6184,7 @@
         </p:nvSpPr>
         <p:spPr>
           <a:xfrm>
-            <a:off x="438912" y="1392173"/>
+            <a:off x="438912" y="1501901"/>
             <a:ext cx="4700016" cy="321564"/>
           </a:xfrm>
           <a:prstGeom prst="rect">
@@ -6218,7 +6218,7 @@
         </p:nvSpPr>
         <p:spPr>
           <a:xfrm>
-            <a:off x="438912" y="1658873"/>
+            <a:off x="438912" y="1823465"/>
             <a:ext cx="4700016" cy="321564"/>
           </a:xfrm>
           <a:prstGeom prst="rect">
@@ -6252,7 +6252,7 @@
         </p:nvSpPr>
         <p:spPr>
           <a:xfrm>
-            <a:off x="438912" y="1925573"/>
+            <a:off x="438912" y="2145029"/>
             <a:ext cx="4700016" cy="321564"/>
           </a:xfrm>
           <a:prstGeom prst="rect">
@@ -6286,7 +6286,7 @@
         </p:nvSpPr>
         <p:spPr>
           <a:xfrm>
-            <a:off x="438912" y="2192273"/>
+            <a:off x="438912" y="2466593"/>
             <a:ext cx="4700016" cy="321564"/>
           </a:xfrm>
           <a:prstGeom prst="rect">
@@ -6320,7 +6320,7 @@
         </p:nvSpPr>
         <p:spPr>
           <a:xfrm>
-            <a:off x="438912" y="2458973"/>
+            <a:off x="438912" y="2788157"/>
             <a:ext cx="4700016" cy="321564"/>
           </a:xfrm>
           <a:prstGeom prst="rect">
@@ -6354,7 +6354,7 @@
         </p:nvSpPr>
         <p:spPr>
           <a:xfrm>
-            <a:off x="438912" y="2725673"/>
+            <a:off x="438912" y="3109721"/>
             <a:ext cx="4700016" cy="302513"/>
           </a:xfrm>
           <a:prstGeom prst="rect">
@@ -6388,7 +6388,7 @@
         </p:nvSpPr>
         <p:spPr>
           <a:xfrm>
-            <a:off x="438912" y="2973322"/>
+            <a:off x="438912" y="3412234"/>
             <a:ext cx="4700016" cy="321564"/>
           </a:xfrm>
           <a:prstGeom prst="rect">
@@ -6422,7 +6422,7 @@
         </p:nvSpPr>
         <p:spPr>
           <a:xfrm>
-            <a:off x="438912" y="3240022"/>
+            <a:off x="438912" y="3733798"/>
             <a:ext cx="4700016" cy="321564"/>
           </a:xfrm>
           <a:prstGeom prst="rect">
@@ -6456,7 +6456,7 @@
         </p:nvSpPr>
         <p:spPr>
           <a:xfrm>
-            <a:off x="438912" y="3506722"/>
+            <a:off x="438912" y="4055362"/>
             <a:ext cx="4700016" cy="321564"/>
           </a:xfrm>
           <a:prstGeom prst="rect">
@@ -6490,7 +6490,7 @@
         </p:nvSpPr>
         <p:spPr>
           <a:xfrm>
-            <a:off x="438912" y="3773422"/>
+            <a:off x="438912" y="4376926"/>
             <a:ext cx="4700016" cy="321564"/>
           </a:xfrm>
           <a:prstGeom prst="rect">
@@ -6524,7 +6524,7 @@
         </p:nvSpPr>
         <p:spPr>
           <a:xfrm>
-            <a:off x="438912" y="4040122"/>
+            <a:off x="438912" y="4698490"/>
             <a:ext cx="4700016" cy="321564"/>
           </a:xfrm>
           <a:prstGeom prst="rect">
@@ -6559,7 +6559,7 @@
         <p:spPr>
           <a:xfrm>
             <a:off x="5394960" y="749808"/>
-            <a:ext cx="3108960" cy="1910334"/>
+            <a:ext cx="3108960" cy="2239518"/>
           </a:xfrm>
           <a:prstGeom prst="rect">
             <a:avLst/>
@@ -6635,7 +6635,7 @@
         </p:nvSpPr>
         <p:spPr>
           <a:xfrm>
-            <a:off x="5559552" y="1125473"/>
+            <a:off x="5559552" y="1180337"/>
             <a:ext cx="2779776" cy="321564"/>
           </a:xfrm>
           <a:prstGeom prst="rect">
@@ -6669,7 +6669,7 @@
         </p:nvSpPr>
         <p:spPr>
           <a:xfrm>
-            <a:off x="5559552" y="1392173"/>
+            <a:off x="5559552" y="1501901"/>
             <a:ext cx="2779776" cy="321564"/>
           </a:xfrm>
           <a:prstGeom prst="rect">
@@ -6703,7 +6703,7 @@
         </p:nvSpPr>
         <p:spPr>
           <a:xfrm>
-            <a:off x="5559552" y="1658873"/>
+            <a:off x="5559552" y="1823465"/>
             <a:ext cx="2779776" cy="321564"/>
           </a:xfrm>
           <a:prstGeom prst="rect">
@@ -6737,7 +6737,7 @@
         </p:nvSpPr>
         <p:spPr>
           <a:xfrm>
-            <a:off x="5559552" y="1925573"/>
+            <a:off x="5559552" y="2145029"/>
             <a:ext cx="2779776" cy="321564"/>
           </a:xfrm>
           <a:prstGeom prst="rect">
@@ -6771,7 +6771,7 @@
         </p:nvSpPr>
         <p:spPr>
           <a:xfrm>
-            <a:off x="5559552" y="2192273"/>
+            <a:off x="5559552" y="2466593"/>
             <a:ext cx="2779776" cy="321564"/>
           </a:xfrm>
           <a:prstGeom prst="rect">
@@ -6805,8 +6805,8 @@
         </p:nvSpPr>
         <p:spPr>
           <a:xfrm>
-            <a:off x="5394960" y="2769870"/>
-            <a:ext cx="3108960" cy="3243834"/>
+            <a:off x="5394960" y="3099054"/>
+            <a:ext cx="3108960" cy="4011929"/>
           </a:xfrm>
           <a:prstGeom prst="rect">
             <a:avLst/>
@@ -6848,7 +6848,7 @@
         </p:nvSpPr>
         <p:spPr>
           <a:xfrm>
-            <a:off x="5559552" y="2897886"/>
+            <a:off x="5559552" y="3227070"/>
             <a:ext cx="2779776" cy="245364"/>
           </a:xfrm>
           <a:prstGeom prst="rect">
@@ -6882,7 +6882,7 @@
         </p:nvSpPr>
         <p:spPr>
           <a:xfrm>
-            <a:off x="5559552" y="3088386"/>
+            <a:off x="5559552" y="3472434"/>
             <a:ext cx="2779776" cy="264414"/>
           </a:xfrm>
           <a:prstGeom prst="rect">
@@ -6916,7 +6916,7 @@
         </p:nvSpPr>
         <p:spPr>
           <a:xfrm>
-            <a:off x="5559552" y="3297936"/>
+            <a:off x="5559552" y="3736848"/>
             <a:ext cx="2779776" cy="264414"/>
           </a:xfrm>
           <a:prstGeom prst="rect">
@@ -6950,7 +6950,7 @@
         </p:nvSpPr>
         <p:spPr>
           <a:xfrm>
-            <a:off x="5559552" y="3507486"/>
+            <a:off x="5559552" y="4001262"/>
             <a:ext cx="2779776" cy="264414"/>
           </a:xfrm>
           <a:prstGeom prst="rect">
@@ -6984,7 +6984,7 @@
         </p:nvSpPr>
         <p:spPr>
           <a:xfrm>
-            <a:off x="5559552" y="3717036"/>
+            <a:off x="5559552" y="4265676"/>
             <a:ext cx="2779776" cy="264414"/>
           </a:xfrm>
           <a:prstGeom prst="rect">
@@ -7018,7 +7018,7 @@
         </p:nvSpPr>
         <p:spPr>
           <a:xfrm>
-            <a:off x="5559552" y="3926586"/>
+            <a:off x="5559552" y="4530090"/>
             <a:ext cx="2779776" cy="264414"/>
           </a:xfrm>
           <a:prstGeom prst="rect">
@@ -7052,7 +7052,7 @@
         </p:nvSpPr>
         <p:spPr>
           <a:xfrm>
-            <a:off x="5559552" y="4136136"/>
+            <a:off x="5559552" y="4794504"/>
             <a:ext cx="2779776" cy="264414"/>
           </a:xfrm>
           <a:prstGeom prst="rect">
@@ -7086,7 +7086,7 @@
         </p:nvSpPr>
         <p:spPr>
           <a:xfrm>
-            <a:off x="5559552" y="4345686"/>
+            <a:off x="5559552" y="5058918"/>
             <a:ext cx="2779776" cy="264414"/>
           </a:xfrm>
           <a:prstGeom prst="rect">
@@ -7120,7 +7120,7 @@
         </p:nvSpPr>
         <p:spPr>
           <a:xfrm>
-            <a:off x="5559552" y="4555236"/>
+            <a:off x="5559552" y="5323332"/>
             <a:ext cx="2779776" cy="264414"/>
           </a:xfrm>
           <a:prstGeom prst="rect">
@@ -7154,7 +7154,7 @@
         </p:nvSpPr>
         <p:spPr>
           <a:xfrm>
-            <a:off x="5559552" y="4764786"/>
+            <a:off x="5559552" y="5587746"/>
             <a:ext cx="2779776" cy="264414"/>
           </a:xfrm>
           <a:prstGeom prst="rect">
@@ -7188,7 +7188,7 @@
         </p:nvSpPr>
         <p:spPr>
           <a:xfrm>
-            <a:off x="5559552" y="4974336"/>
+            <a:off x="5559552" y="5852160"/>
             <a:ext cx="2779776" cy="264414"/>
           </a:xfrm>
           <a:prstGeom prst="rect">
@@ -7222,7 +7222,7 @@
         </p:nvSpPr>
         <p:spPr>
           <a:xfrm>
-            <a:off x="5559552" y="5183886"/>
+            <a:off x="5559552" y="6116574"/>
             <a:ext cx="2779776" cy="264414"/>
           </a:xfrm>
           <a:prstGeom prst="rect">
@@ -7256,7 +7256,7 @@
         </p:nvSpPr>
         <p:spPr>
           <a:xfrm>
-            <a:off x="5559552" y="5393436"/>
+            <a:off x="5559552" y="6380988"/>
             <a:ext cx="2779776" cy="264414"/>
           </a:xfrm>
           <a:prstGeom prst="rect">
@@ -7290,7 +7290,7 @@
         </p:nvSpPr>
         <p:spPr>
           <a:xfrm>
-            <a:off x="5559552" y="5602986"/>
+            <a:off x="5559552" y="6645402"/>
             <a:ext cx="2779776" cy="264414"/>
           </a:xfrm>
           <a:prstGeom prst="rect">
@@ -7487,7 +7487,7 @@
         <p:spPr>
           <a:xfrm>
             <a:off x="274320" y="749808"/>
-            <a:ext cx="4937760" cy="2177034"/>
+            <a:ext cx="4937760" cy="2561082"/>
           </a:xfrm>
           <a:prstGeom prst="rect">
             <a:avLst/>
@@ -7563,7 +7563,7 @@
         </p:nvSpPr>
         <p:spPr>
           <a:xfrm>
-            <a:off x="438912" y="1125473"/>
+            <a:off x="438912" y="1180337"/>
             <a:ext cx="4608576" cy="321564"/>
           </a:xfrm>
           <a:prstGeom prst="rect">
@@ -7597,7 +7597,7 @@
         </p:nvSpPr>
         <p:spPr>
           <a:xfrm>
-            <a:off x="438912" y="1392173"/>
+            <a:off x="438912" y="1501901"/>
             <a:ext cx="4608576" cy="321564"/>
           </a:xfrm>
           <a:prstGeom prst="rect">
@@ -7631,7 +7631,7 @@
         </p:nvSpPr>
         <p:spPr>
           <a:xfrm>
-            <a:off x="438912" y="1658873"/>
+            <a:off x="438912" y="1823465"/>
             <a:ext cx="4608576" cy="321564"/>
           </a:xfrm>
           <a:prstGeom prst="rect">
@@ -7665,7 +7665,7 @@
         </p:nvSpPr>
         <p:spPr>
           <a:xfrm>
-            <a:off x="438912" y="1925573"/>
+            <a:off x="438912" y="2145029"/>
             <a:ext cx="4608576" cy="321564"/>
           </a:xfrm>
           <a:prstGeom prst="rect">
@@ -7699,7 +7699,7 @@
         </p:nvSpPr>
         <p:spPr>
           <a:xfrm>
-            <a:off x="438912" y="2192273"/>
+            <a:off x="438912" y="2466593"/>
             <a:ext cx="4608576" cy="321564"/>
           </a:xfrm>
           <a:prstGeom prst="rect">
@@ -7733,7 +7733,7 @@
         </p:nvSpPr>
         <p:spPr>
           <a:xfrm>
-            <a:off x="438912" y="2458973"/>
+            <a:off x="438912" y="2788157"/>
             <a:ext cx="4608576" cy="321564"/>
           </a:xfrm>
           <a:prstGeom prst="rect">
@@ -7768,7 +7768,7 @@
         <p:spPr>
           <a:xfrm>
             <a:off x="5349240" y="749808"/>
-            <a:ext cx="3200400" cy="2691384"/>
+            <a:ext cx="3200400" cy="3185159"/>
           </a:xfrm>
           <a:prstGeom prst="rect">
             <a:avLst/>
@@ -7844,7 +7844,7 @@
         </p:nvSpPr>
         <p:spPr>
           <a:xfrm>
-            <a:off x="5513832" y="1125473"/>
+            <a:off x="5513832" y="1180337"/>
             <a:ext cx="2871216" cy="321564"/>
           </a:xfrm>
           <a:prstGeom prst="rect">
@@ -7878,7 +7878,7 @@
         </p:nvSpPr>
         <p:spPr>
           <a:xfrm>
-            <a:off x="5513832" y="1392173"/>
+            <a:off x="5513832" y="1501901"/>
             <a:ext cx="2871216" cy="321564"/>
           </a:xfrm>
           <a:prstGeom prst="rect">
@@ -7912,7 +7912,7 @@
         </p:nvSpPr>
         <p:spPr>
           <a:xfrm>
-            <a:off x="5513832" y="1658873"/>
+            <a:off x="5513832" y="1823465"/>
             <a:ext cx="2871216" cy="321564"/>
           </a:xfrm>
           <a:prstGeom prst="rect">
@@ -7946,7 +7946,7 @@
         </p:nvSpPr>
         <p:spPr>
           <a:xfrm>
-            <a:off x="5513832" y="1925573"/>
+            <a:off x="5513832" y="2145029"/>
             <a:ext cx="2871216" cy="321564"/>
           </a:xfrm>
           <a:prstGeom prst="rect">
@@ -7980,7 +7980,7 @@
         </p:nvSpPr>
         <p:spPr>
           <a:xfrm>
-            <a:off x="5513832" y="2192273"/>
+            <a:off x="5513832" y="2466593"/>
             <a:ext cx="2871216" cy="302513"/>
           </a:xfrm>
           <a:prstGeom prst="rect">
@@ -8014,7 +8014,7 @@
         </p:nvSpPr>
         <p:spPr>
           <a:xfrm>
-            <a:off x="5513832" y="2439922"/>
+            <a:off x="5513832" y="2769106"/>
             <a:ext cx="2871216" cy="321564"/>
           </a:xfrm>
           <a:prstGeom prst="rect">
@@ -8048,7 +8048,7 @@
         </p:nvSpPr>
         <p:spPr>
           <a:xfrm>
-            <a:off x="5513832" y="2706622"/>
+            <a:off x="5513832" y="3090670"/>
             <a:ext cx="2871216" cy="321564"/>
           </a:xfrm>
           <a:prstGeom prst="rect">
@@ -8082,7 +8082,7 @@
         </p:nvSpPr>
         <p:spPr>
           <a:xfrm>
-            <a:off x="5513832" y="2973322"/>
+            <a:off x="5513832" y="3412234"/>
             <a:ext cx="2871216" cy="321564"/>
           </a:xfrm>
           <a:prstGeom prst="rect">
@@ -8116,8 +8116,8 @@
         </p:nvSpPr>
         <p:spPr>
           <a:xfrm>
-            <a:off x="274320" y="3569208"/>
-            <a:ext cx="8229600" cy="2958084"/>
+            <a:off x="274320" y="4062983"/>
+            <a:ext cx="8229600" cy="3506723"/>
           </a:xfrm>
           <a:prstGeom prst="rect">
             <a:avLst/>
@@ -8159,7 +8159,7 @@
         </p:nvSpPr>
         <p:spPr>
           <a:xfrm>
-            <a:off x="438912" y="3697224"/>
+            <a:off x="438912" y="4190999"/>
             <a:ext cx="7900416" cy="302513"/>
           </a:xfrm>
           <a:prstGeom prst="rect">
@@ -8193,7 +8193,7 @@
         </p:nvSpPr>
         <p:spPr>
           <a:xfrm>
-            <a:off x="438912" y="3944873"/>
+            <a:off x="438912" y="4493512"/>
             <a:ext cx="7900416" cy="321564"/>
           </a:xfrm>
           <a:prstGeom prst="rect">
@@ -8227,7 +8227,7 @@
         </p:nvSpPr>
         <p:spPr>
           <a:xfrm>
-            <a:off x="438912" y="4211573"/>
+            <a:off x="438912" y="4815076"/>
             <a:ext cx="7900416" cy="321564"/>
           </a:xfrm>
           <a:prstGeom prst="rect">
@@ -8261,7 +8261,7 @@
         </p:nvSpPr>
         <p:spPr>
           <a:xfrm>
-            <a:off x="438912" y="4478273"/>
+            <a:off x="438912" y="5136640"/>
             <a:ext cx="7900416" cy="321564"/>
           </a:xfrm>
           <a:prstGeom prst="rect">
@@ -8295,7 +8295,7 @@
         </p:nvSpPr>
         <p:spPr>
           <a:xfrm>
-            <a:off x="438912" y="4744973"/>
+            <a:off x="438912" y="5458204"/>
             <a:ext cx="7900416" cy="321564"/>
           </a:xfrm>
           <a:prstGeom prst="rect">
@@ -8329,7 +8329,7 @@
         </p:nvSpPr>
         <p:spPr>
           <a:xfrm>
-            <a:off x="438912" y="5011673"/>
+            <a:off x="438912" y="5779768"/>
             <a:ext cx="7900416" cy="321564"/>
           </a:xfrm>
           <a:prstGeom prst="rect">
@@ -8363,7 +8363,7 @@
         </p:nvSpPr>
         <p:spPr>
           <a:xfrm>
-            <a:off x="438912" y="5278373"/>
+            <a:off x="438912" y="6101332"/>
             <a:ext cx="7900416" cy="321564"/>
           </a:xfrm>
           <a:prstGeom prst="rect">
@@ -8397,7 +8397,7 @@
         </p:nvSpPr>
         <p:spPr>
           <a:xfrm>
-            <a:off x="438912" y="5545073"/>
+            <a:off x="438912" y="6422896"/>
             <a:ext cx="7900416" cy="302513"/>
           </a:xfrm>
           <a:prstGeom prst="rect">
@@ -8431,7 +8431,7 @@
         </p:nvSpPr>
         <p:spPr>
           <a:xfrm>
-            <a:off x="438912" y="5792722"/>
+            <a:off x="438912" y="6725409"/>
             <a:ext cx="7900416" cy="321564"/>
           </a:xfrm>
           <a:prstGeom prst="rect">
@@ -8465,7 +8465,7 @@
         </p:nvSpPr>
         <p:spPr>
           <a:xfrm>
-            <a:off x="438912" y="6059422"/>
+            <a:off x="438912" y="7046973"/>
             <a:ext cx="7900416" cy="321564"/>
           </a:xfrm>
           <a:prstGeom prst="rect">
@@ -8662,7 +8662,7 @@
         <p:spPr>
           <a:xfrm>
             <a:off x="274320" y="749808"/>
-            <a:ext cx="4937760" cy="2443734"/>
+            <a:ext cx="4937760" cy="2882646"/>
           </a:xfrm>
           <a:prstGeom prst="rect">
             <a:avLst/>
@@ -8738,7 +8738,7 @@
         </p:nvSpPr>
         <p:spPr>
           <a:xfrm>
-            <a:off x="438912" y="1125473"/>
+            <a:off x="438912" y="1180337"/>
             <a:ext cx="4608576" cy="321564"/>
           </a:xfrm>
           <a:prstGeom prst="rect">
@@ -8772,7 +8772,7 @@
         </p:nvSpPr>
         <p:spPr>
           <a:xfrm>
-            <a:off x="438912" y="1392173"/>
+            <a:off x="438912" y="1501901"/>
             <a:ext cx="4608576" cy="321564"/>
           </a:xfrm>
           <a:prstGeom prst="rect">
@@ -8806,7 +8806,7 @@
         </p:nvSpPr>
         <p:spPr>
           <a:xfrm>
-            <a:off x="438912" y="1658873"/>
+            <a:off x="438912" y="1823465"/>
             <a:ext cx="4608576" cy="321564"/>
           </a:xfrm>
           <a:prstGeom prst="rect">
@@ -8840,7 +8840,7 @@
         </p:nvSpPr>
         <p:spPr>
           <a:xfrm>
-            <a:off x="438912" y="1925573"/>
+            <a:off x="438912" y="2145029"/>
             <a:ext cx="4608576" cy="321564"/>
           </a:xfrm>
           <a:prstGeom prst="rect">
@@ -8874,7 +8874,7 @@
         </p:nvSpPr>
         <p:spPr>
           <a:xfrm>
-            <a:off x="438912" y="2192273"/>
+            <a:off x="438912" y="2466593"/>
             <a:ext cx="4608576" cy="321564"/>
           </a:xfrm>
           <a:prstGeom prst="rect">
@@ -8908,7 +8908,7 @@
         </p:nvSpPr>
         <p:spPr>
           <a:xfrm>
-            <a:off x="438912" y="2458973"/>
+            <a:off x="438912" y="2788157"/>
             <a:ext cx="4608576" cy="321564"/>
           </a:xfrm>
           <a:prstGeom prst="rect">
@@ -8942,7 +8942,7 @@
         </p:nvSpPr>
         <p:spPr>
           <a:xfrm>
-            <a:off x="438912" y="2725673"/>
+            <a:off x="438912" y="3109721"/>
             <a:ext cx="4608576" cy="321564"/>
           </a:xfrm>
           <a:prstGeom prst="rect">
@@ -8977,7 +8977,7 @@
         <p:spPr>
           <a:xfrm>
             <a:off x="5349240" y="749808"/>
-            <a:ext cx="3200400" cy="2958084"/>
+            <a:ext cx="3200400" cy="3506723"/>
           </a:xfrm>
           <a:prstGeom prst="rect">
             <a:avLst/>
@@ -9053,7 +9053,7 @@
         </p:nvSpPr>
         <p:spPr>
           <a:xfrm>
-            <a:off x="5513832" y="1125473"/>
+            <a:off x="5513832" y="1180337"/>
             <a:ext cx="2871216" cy="321564"/>
           </a:xfrm>
           <a:prstGeom prst="rect">
@@ -9087,7 +9087,7 @@
         </p:nvSpPr>
         <p:spPr>
           <a:xfrm>
-            <a:off x="5513832" y="1392173"/>
+            <a:off x="5513832" y="1501901"/>
             <a:ext cx="2871216" cy="321564"/>
           </a:xfrm>
           <a:prstGeom prst="rect">
@@ -9121,7 +9121,7 @@
         </p:nvSpPr>
         <p:spPr>
           <a:xfrm>
-            <a:off x="5513832" y="1658873"/>
+            <a:off x="5513832" y="1823465"/>
             <a:ext cx="2871216" cy="321564"/>
           </a:xfrm>
           <a:prstGeom prst="rect">
@@ -9155,7 +9155,7 @@
         </p:nvSpPr>
         <p:spPr>
           <a:xfrm>
-            <a:off x="5513832" y="1925573"/>
+            <a:off x="5513832" y="2145029"/>
             <a:ext cx="2871216" cy="321564"/>
           </a:xfrm>
           <a:prstGeom prst="rect">
@@ -9189,7 +9189,7 @@
         </p:nvSpPr>
         <p:spPr>
           <a:xfrm>
-            <a:off x="5513832" y="2192273"/>
+            <a:off x="5513832" y="2466593"/>
             <a:ext cx="2871216" cy="302513"/>
           </a:xfrm>
           <a:prstGeom prst="rect">
@@ -9223,7 +9223,7 @@
         </p:nvSpPr>
         <p:spPr>
           <a:xfrm>
-            <a:off x="5513832" y="2439922"/>
+            <a:off x="5513832" y="2769106"/>
             <a:ext cx="2871216" cy="321564"/>
           </a:xfrm>
           <a:prstGeom prst="rect">
@@ -9257,7 +9257,7 @@
         </p:nvSpPr>
         <p:spPr>
           <a:xfrm>
-            <a:off x="5513832" y="2706622"/>
+            <a:off x="5513832" y="3090670"/>
             <a:ext cx="2871216" cy="321564"/>
           </a:xfrm>
           <a:prstGeom prst="rect">
@@ -9291,7 +9291,7 @@
         </p:nvSpPr>
         <p:spPr>
           <a:xfrm>
-            <a:off x="5513832" y="2973322"/>
+            <a:off x="5513832" y="3412234"/>
             <a:ext cx="2871216" cy="321564"/>
           </a:xfrm>
           <a:prstGeom prst="rect">
@@ -9325,7 +9325,7 @@
         </p:nvSpPr>
         <p:spPr>
           <a:xfrm>
-            <a:off x="5513832" y="3240022"/>
+            <a:off x="5513832" y="3733798"/>
             <a:ext cx="2871216" cy="321564"/>
           </a:xfrm>
           <a:prstGeom prst="rect">
@@ -9359,8 +9359,8 @@
         </p:nvSpPr>
         <p:spPr>
           <a:xfrm>
-            <a:off x="274320" y="3835908"/>
-            <a:ext cx="8229600" cy="2767584"/>
+            <a:off x="274320" y="4384547"/>
+            <a:ext cx="8229600" cy="3316224"/>
           </a:xfrm>
           <a:prstGeom prst="rect">
             <a:avLst/>
@@ -9402,7 +9402,7 @@
         </p:nvSpPr>
         <p:spPr>
           <a:xfrm>
-            <a:off x="438912" y="3963924"/>
+            <a:off x="438912" y="4512563"/>
             <a:ext cx="7900416" cy="283464"/>
           </a:xfrm>
           <a:prstGeom prst="rect">
@@ -9436,7 +9436,7 @@
         </p:nvSpPr>
         <p:spPr>
           <a:xfrm>
-            <a:off x="438912" y="4192524"/>
+            <a:off x="438912" y="4796027"/>
             <a:ext cx="7900416" cy="302513"/>
           </a:xfrm>
           <a:prstGeom prst="rect">
@@ -9470,7 +9470,7 @@
         </p:nvSpPr>
         <p:spPr>
           <a:xfrm>
-            <a:off x="438912" y="4440173"/>
+            <a:off x="438912" y="5098540"/>
             <a:ext cx="7900416" cy="302513"/>
           </a:xfrm>
           <a:prstGeom prst="rect">
@@ -9504,7 +9504,7 @@
         </p:nvSpPr>
         <p:spPr>
           <a:xfrm>
-            <a:off x="438912" y="4687822"/>
+            <a:off x="438912" y="5401053"/>
             <a:ext cx="7900416" cy="302513"/>
           </a:xfrm>
           <a:prstGeom prst="rect">
@@ -9538,7 +9538,7 @@
         </p:nvSpPr>
         <p:spPr>
           <a:xfrm>
-            <a:off x="438912" y="4935471"/>
+            <a:off x="438912" y="5703566"/>
             <a:ext cx="7900416" cy="302513"/>
           </a:xfrm>
           <a:prstGeom prst="rect">
@@ -9572,7 +9572,7 @@
         </p:nvSpPr>
         <p:spPr>
           <a:xfrm>
-            <a:off x="438912" y="5183120"/>
+            <a:off x="438912" y="6006079"/>
             <a:ext cx="7900416" cy="302513"/>
           </a:xfrm>
           <a:prstGeom prst="rect">
@@ -9606,7 +9606,7 @@
         </p:nvSpPr>
         <p:spPr>
           <a:xfrm>
-            <a:off x="438912" y="5430769"/>
+            <a:off x="438912" y="6308592"/>
             <a:ext cx="7900416" cy="283464"/>
           </a:xfrm>
           <a:prstGeom prst="rect">
@@ -9640,7 +9640,7 @@
         </p:nvSpPr>
         <p:spPr>
           <a:xfrm>
-            <a:off x="438912" y="5659369"/>
+            <a:off x="438912" y="6592056"/>
             <a:ext cx="7900416" cy="302513"/>
           </a:xfrm>
           <a:prstGeom prst="rect">
@@ -9674,7 +9674,7 @@
         </p:nvSpPr>
         <p:spPr>
           <a:xfrm>
-            <a:off x="438912" y="5907018"/>
+            <a:off x="438912" y="6894569"/>
             <a:ext cx="7900416" cy="302513"/>
           </a:xfrm>
           <a:prstGeom prst="rect">
@@ -9708,7 +9708,7 @@
         </p:nvSpPr>
         <p:spPr>
           <a:xfrm>
-            <a:off x="438912" y="6154667"/>
+            <a:off x="438912" y="7197082"/>
             <a:ext cx="7900416" cy="302513"/>
           </a:xfrm>
           <a:prstGeom prst="rect">
@@ -9960,7 +9960,7 @@
         <p:spPr>
           <a:xfrm>
             <a:off x="274320" y="749808"/>
-            <a:ext cx="4937760" cy="2710434"/>
+            <a:ext cx="4937760" cy="3204210"/>
           </a:xfrm>
           <a:prstGeom prst="rect">
             <a:avLst/>
@@ -10036,7 +10036,7 @@
         </p:nvSpPr>
         <p:spPr>
           <a:xfrm>
-            <a:off x="438912" y="1125473"/>
+            <a:off x="438912" y="1180337"/>
             <a:ext cx="4608576" cy="321564"/>
           </a:xfrm>
           <a:prstGeom prst="rect">
@@ -10070,7 +10070,7 @@
         </p:nvSpPr>
         <p:spPr>
           <a:xfrm>
-            <a:off x="438912" y="1392173"/>
+            <a:off x="438912" y="1501901"/>
             <a:ext cx="4608576" cy="321564"/>
           </a:xfrm>
           <a:prstGeom prst="rect">
@@ -10104,7 +10104,7 @@
         </p:nvSpPr>
         <p:spPr>
           <a:xfrm>
-            <a:off x="438912" y="1658873"/>
+            <a:off x="438912" y="1823465"/>
             <a:ext cx="4608576" cy="321564"/>
           </a:xfrm>
           <a:prstGeom prst="rect">
@@ -10138,7 +10138,7 @@
         </p:nvSpPr>
         <p:spPr>
           <a:xfrm>
-            <a:off x="438912" y="1925573"/>
+            <a:off x="438912" y="2145029"/>
             <a:ext cx="4608576" cy="321564"/>
           </a:xfrm>
           <a:prstGeom prst="rect">
@@ -10172,7 +10172,7 @@
         </p:nvSpPr>
         <p:spPr>
           <a:xfrm>
-            <a:off x="438912" y="2192273"/>
+            <a:off x="438912" y="2466593"/>
             <a:ext cx="4608576" cy="321564"/>
           </a:xfrm>
           <a:prstGeom prst="rect">
@@ -10206,7 +10206,7 @@
         </p:nvSpPr>
         <p:spPr>
           <a:xfrm>
-            <a:off x="438912" y="2458973"/>
+            <a:off x="438912" y="2788157"/>
             <a:ext cx="4608576" cy="321564"/>
           </a:xfrm>
           <a:prstGeom prst="rect">
@@ -10240,7 +10240,7 @@
         </p:nvSpPr>
         <p:spPr>
           <a:xfrm>
-            <a:off x="438912" y="2725673"/>
+            <a:off x="438912" y="3109721"/>
             <a:ext cx="4608576" cy="321564"/>
           </a:xfrm>
           <a:prstGeom prst="rect">
@@ -10274,7 +10274,7 @@
         </p:nvSpPr>
         <p:spPr>
           <a:xfrm>
-            <a:off x="438912" y="2992373"/>
+            <a:off x="438912" y="3431285"/>
             <a:ext cx="4608576" cy="321564"/>
           </a:xfrm>
           <a:prstGeom prst="rect">
@@ -10309,7 +10309,7 @@
         <p:spPr>
           <a:xfrm>
             <a:off x="5349240" y="749808"/>
-            <a:ext cx="3200400" cy="2958084"/>
+            <a:ext cx="3200400" cy="3506723"/>
           </a:xfrm>
           <a:prstGeom prst="rect">
             <a:avLst/>
@@ -10385,7 +10385,7 @@
         </p:nvSpPr>
         <p:spPr>
           <a:xfrm>
-            <a:off x="5513832" y="1125473"/>
+            <a:off x="5513832" y="1180337"/>
             <a:ext cx="2871216" cy="321564"/>
           </a:xfrm>
           <a:prstGeom prst="rect">
@@ -10419,7 +10419,7 @@
         </p:nvSpPr>
         <p:spPr>
           <a:xfrm>
-            <a:off x="5513832" y="1392173"/>
+            <a:off x="5513832" y="1501901"/>
             <a:ext cx="2871216" cy="321564"/>
           </a:xfrm>
           <a:prstGeom prst="rect">
@@ -10453,7 +10453,7 @@
         </p:nvSpPr>
         <p:spPr>
           <a:xfrm>
-            <a:off x="5513832" y="1658873"/>
+            <a:off x="5513832" y="1823465"/>
             <a:ext cx="2871216" cy="321564"/>
           </a:xfrm>
           <a:prstGeom prst="rect">
@@ -10487,7 +10487,7 @@
         </p:nvSpPr>
         <p:spPr>
           <a:xfrm>
-            <a:off x="5513832" y="1925573"/>
+            <a:off x="5513832" y="2145029"/>
             <a:ext cx="2871216" cy="321564"/>
           </a:xfrm>
           <a:prstGeom prst="rect">
@@ -10521,7 +10521,7 @@
         </p:nvSpPr>
         <p:spPr>
           <a:xfrm>
-            <a:off x="5513832" y="2192273"/>
+            <a:off x="5513832" y="2466593"/>
             <a:ext cx="2871216" cy="321564"/>
           </a:xfrm>
           <a:prstGeom prst="rect">
@@ -10555,7 +10555,7 @@
         </p:nvSpPr>
         <p:spPr>
           <a:xfrm>
-            <a:off x="5513832" y="2458973"/>
+            <a:off x="5513832" y="2788157"/>
             <a:ext cx="2871216" cy="302513"/>
           </a:xfrm>
           <a:prstGeom prst="rect">
@@ -10589,7 +10589,7 @@
         </p:nvSpPr>
         <p:spPr>
           <a:xfrm>
-            <a:off x="5513832" y="2706622"/>
+            <a:off x="5513832" y="3090670"/>
             <a:ext cx="2871216" cy="321564"/>
           </a:xfrm>
           <a:prstGeom prst="rect">
@@ -10623,7 +10623,7 @@
         </p:nvSpPr>
         <p:spPr>
           <a:xfrm>
-            <a:off x="5513832" y="2973322"/>
+            <a:off x="5513832" y="3412234"/>
             <a:ext cx="2871216" cy="321564"/>
           </a:xfrm>
           <a:prstGeom prst="rect">
@@ -10657,7 +10657,7 @@
         </p:nvSpPr>
         <p:spPr>
           <a:xfrm>
-            <a:off x="5513832" y="3240022"/>
+            <a:off x="5513832" y="3733798"/>
             <a:ext cx="2871216" cy="321564"/>
           </a:xfrm>
           <a:prstGeom prst="rect">
@@ -10691,8 +10691,8 @@
         </p:nvSpPr>
         <p:spPr>
           <a:xfrm>
-            <a:off x="274320" y="3835908"/>
-            <a:ext cx="8229600" cy="2767584"/>
+            <a:off x="274320" y="4384547"/>
+            <a:ext cx="8229600" cy="3316224"/>
           </a:xfrm>
           <a:prstGeom prst="rect">
             <a:avLst/>
@@ -10734,7 +10734,7 @@
         </p:nvSpPr>
         <p:spPr>
           <a:xfrm>
-            <a:off x="438912" y="3963924"/>
+            <a:off x="438912" y="4512563"/>
             <a:ext cx="7900416" cy="283464"/>
           </a:xfrm>
           <a:prstGeom prst="rect">
@@ -10768,7 +10768,7 @@
         </p:nvSpPr>
         <p:spPr>
           <a:xfrm>
-            <a:off x="438912" y="4192524"/>
+            <a:off x="438912" y="4796027"/>
             <a:ext cx="7900416" cy="302513"/>
           </a:xfrm>
           <a:prstGeom prst="rect">
@@ -10802,7 +10802,7 @@
         </p:nvSpPr>
         <p:spPr>
           <a:xfrm>
-            <a:off x="438912" y="4440173"/>
+            <a:off x="438912" y="5098540"/>
             <a:ext cx="7900416" cy="302513"/>
           </a:xfrm>
           <a:prstGeom prst="rect">
@@ -10836,7 +10836,7 @@
         </p:nvSpPr>
         <p:spPr>
           <a:xfrm>
-            <a:off x="438912" y="4687822"/>
+            <a:off x="438912" y="5401053"/>
             <a:ext cx="7900416" cy="302513"/>
           </a:xfrm>
           <a:prstGeom prst="rect">
@@ -10870,7 +10870,7 @@
         </p:nvSpPr>
         <p:spPr>
           <a:xfrm>
-            <a:off x="438912" y="4935471"/>
+            <a:off x="438912" y="5703566"/>
             <a:ext cx="7900416" cy="302513"/>
           </a:xfrm>
           <a:prstGeom prst="rect">
@@ -10904,7 +10904,7 @@
         </p:nvSpPr>
         <p:spPr>
           <a:xfrm>
-            <a:off x="438912" y="5183120"/>
+            <a:off x="438912" y="6006079"/>
             <a:ext cx="7900416" cy="283464"/>
           </a:xfrm>
           <a:prstGeom prst="rect">
@@ -10938,7 +10938,7 @@
         </p:nvSpPr>
         <p:spPr>
           <a:xfrm>
-            <a:off x="438912" y="5411720"/>
+            <a:off x="438912" y="6289543"/>
             <a:ext cx="7900416" cy="302513"/>
           </a:xfrm>
           <a:prstGeom prst="rect">
@@ -10972,7 +10972,7 @@
         </p:nvSpPr>
         <p:spPr>
           <a:xfrm>
-            <a:off x="438912" y="5659369"/>
+            <a:off x="438912" y="6592056"/>
             <a:ext cx="7900416" cy="302513"/>
           </a:xfrm>
           <a:prstGeom prst="rect">
@@ -11006,7 +11006,7 @@
         </p:nvSpPr>
         <p:spPr>
           <a:xfrm>
-            <a:off x="438912" y="5907018"/>
+            <a:off x="438912" y="6894569"/>
             <a:ext cx="7900416" cy="302513"/>
           </a:xfrm>
           <a:prstGeom prst="rect">
@@ -11040,7 +11040,7 @@
         </p:nvSpPr>
         <p:spPr>
           <a:xfrm>
-            <a:off x="438912" y="6154667"/>
+            <a:off x="438912" y="7197082"/>
             <a:ext cx="7900416" cy="302513"/>
           </a:xfrm>
           <a:prstGeom prst="rect">
@@ -11237,7 +11237,7 @@
         <p:spPr>
           <a:xfrm>
             <a:off x="274320" y="749808"/>
-            <a:ext cx="4937760" cy="2177034"/>
+            <a:ext cx="4937760" cy="2561082"/>
           </a:xfrm>
           <a:prstGeom prst="rect">
             <a:avLst/>
@@ -11313,7 +11313,7 @@
         </p:nvSpPr>
         <p:spPr>
           <a:xfrm>
-            <a:off x="438912" y="1125473"/>
+            <a:off x="438912" y="1180337"/>
             <a:ext cx="4608576" cy="321564"/>
           </a:xfrm>
           <a:prstGeom prst="rect">
@@ -11347,7 +11347,7 @@
         </p:nvSpPr>
         <p:spPr>
           <a:xfrm>
-            <a:off x="438912" y="1392173"/>
+            <a:off x="438912" y="1501901"/>
             <a:ext cx="4608576" cy="321564"/>
           </a:xfrm>
           <a:prstGeom prst="rect">
@@ -11381,7 +11381,7 @@
         </p:nvSpPr>
         <p:spPr>
           <a:xfrm>
-            <a:off x="438912" y="1658873"/>
+            <a:off x="438912" y="1823465"/>
             <a:ext cx="4608576" cy="321564"/>
           </a:xfrm>
           <a:prstGeom prst="rect">
@@ -11415,7 +11415,7 @@
         </p:nvSpPr>
         <p:spPr>
           <a:xfrm>
-            <a:off x="438912" y="1925573"/>
+            <a:off x="438912" y="2145029"/>
             <a:ext cx="4608576" cy="321564"/>
           </a:xfrm>
           <a:prstGeom prst="rect">
@@ -11449,7 +11449,7 @@
         </p:nvSpPr>
         <p:spPr>
           <a:xfrm>
-            <a:off x="438912" y="2192273"/>
+            <a:off x="438912" y="2466593"/>
             <a:ext cx="4608576" cy="321564"/>
           </a:xfrm>
           <a:prstGeom prst="rect">
@@ -11483,7 +11483,7 @@
         </p:nvSpPr>
         <p:spPr>
           <a:xfrm>
-            <a:off x="438912" y="2458973"/>
+            <a:off x="438912" y="2788157"/>
             <a:ext cx="4608576" cy="321564"/>
           </a:xfrm>
           <a:prstGeom prst="rect">
@@ -11517,8 +11517,8 @@
         </p:nvSpPr>
         <p:spPr>
           <a:xfrm>
-            <a:off x="274320" y="3054858"/>
-            <a:ext cx="2743200" cy="2043684"/>
+            <a:off x="274320" y="3438906"/>
+            <a:ext cx="2743200" cy="2427732"/>
           </a:xfrm>
           <a:prstGeom prst="rect">
             <a:avLst/>
@@ -11560,7 +11560,7 @@
         </p:nvSpPr>
         <p:spPr>
           <a:xfrm>
-            <a:off x="438912" y="3182874"/>
+            <a:off x="438912" y="3566922"/>
             <a:ext cx="2414016" cy="283464"/>
           </a:xfrm>
           <a:prstGeom prst="rect">
@@ -11594,7 +11594,7 @@
         </p:nvSpPr>
         <p:spPr>
           <a:xfrm>
-            <a:off x="438912" y="3411474"/>
+            <a:off x="438912" y="3850386"/>
             <a:ext cx="2414016" cy="302513"/>
           </a:xfrm>
           <a:prstGeom prst="rect">
@@ -11628,7 +11628,7 @@
         </p:nvSpPr>
         <p:spPr>
           <a:xfrm>
-            <a:off x="438912" y="3659123"/>
+            <a:off x="438912" y="4152899"/>
             <a:ext cx="2414016" cy="302513"/>
           </a:xfrm>
           <a:prstGeom prst="rect">
@@ -11662,7 +11662,7 @@
         </p:nvSpPr>
         <p:spPr>
           <a:xfrm>
-            <a:off x="438912" y="3906772"/>
+            <a:off x="438912" y="4455412"/>
             <a:ext cx="2414016" cy="302513"/>
           </a:xfrm>
           <a:prstGeom prst="rect">
@@ -11696,7 +11696,7 @@
         </p:nvSpPr>
         <p:spPr>
           <a:xfrm>
-            <a:off x="438912" y="4154421"/>
+            <a:off x="438912" y="4757925"/>
             <a:ext cx="2414016" cy="302513"/>
           </a:xfrm>
           <a:prstGeom prst="rect">
@@ -11730,7 +11730,7 @@
         </p:nvSpPr>
         <p:spPr>
           <a:xfrm>
-            <a:off x="438912" y="4402070"/>
+            <a:off x="438912" y="5060438"/>
             <a:ext cx="2414016" cy="302513"/>
           </a:xfrm>
           <a:prstGeom prst="rect">
@@ -11764,7 +11764,7 @@
         </p:nvSpPr>
         <p:spPr>
           <a:xfrm>
-            <a:off x="438912" y="4649719"/>
+            <a:off x="438912" y="5362951"/>
             <a:ext cx="2414016" cy="302513"/>
           </a:xfrm>
           <a:prstGeom prst="rect">
@@ -11798,8 +11798,8 @@
         </p:nvSpPr>
         <p:spPr>
           <a:xfrm>
-            <a:off x="3108960" y="3054858"/>
-            <a:ext cx="2743200" cy="2043684"/>
+            <a:off x="3108960" y="3438906"/>
+            <a:ext cx="2743200" cy="2427732"/>
           </a:xfrm>
           <a:prstGeom prst="rect">
             <a:avLst/>
@@ -11841,7 +11841,7 @@
         </p:nvSpPr>
         <p:spPr>
           <a:xfrm>
-            <a:off x="3273552" y="3182874"/>
+            <a:off x="3273552" y="3566922"/>
             <a:ext cx="2414016" cy="283464"/>
           </a:xfrm>
           <a:prstGeom prst="rect">
@@ -11875,7 +11875,7 @@
         </p:nvSpPr>
         <p:spPr>
           <a:xfrm>
-            <a:off x="3273552" y="3411474"/>
+            <a:off x="3273552" y="3850386"/>
             <a:ext cx="2414016" cy="302513"/>
           </a:xfrm>
           <a:prstGeom prst="rect">
@@ -11909,7 +11909,7 @@
         </p:nvSpPr>
         <p:spPr>
           <a:xfrm>
-            <a:off x="3273552" y="3659123"/>
+            <a:off x="3273552" y="4152899"/>
             <a:ext cx="2414016" cy="302513"/>
           </a:xfrm>
           <a:prstGeom prst="rect">
@@ -11943,7 +11943,7 @@
         </p:nvSpPr>
         <p:spPr>
           <a:xfrm>
-            <a:off x="3273552" y="3906772"/>
+            <a:off x="3273552" y="4455412"/>
             <a:ext cx="2414016" cy="302513"/>
           </a:xfrm>
           <a:prstGeom prst="rect">
@@ -11977,7 +11977,7 @@
         </p:nvSpPr>
         <p:spPr>
           <a:xfrm>
-            <a:off x="3273552" y="4154421"/>
+            <a:off x="3273552" y="4757925"/>
             <a:ext cx="2414016" cy="302513"/>
           </a:xfrm>
           <a:prstGeom prst="rect">
@@ -12011,7 +12011,7 @@
         </p:nvSpPr>
         <p:spPr>
           <a:xfrm>
-            <a:off x="3273552" y="4402070"/>
+            <a:off x="3273552" y="5060438"/>
             <a:ext cx="2414016" cy="302513"/>
           </a:xfrm>
           <a:prstGeom prst="rect">
@@ -12045,7 +12045,7 @@
         </p:nvSpPr>
         <p:spPr>
           <a:xfrm>
-            <a:off x="3273552" y="4649719"/>
+            <a:off x="3273552" y="5362951"/>
             <a:ext cx="2414016" cy="302513"/>
           </a:xfrm>
           <a:prstGeom prst="rect">
@@ -12079,8 +12079,8 @@
         </p:nvSpPr>
         <p:spPr>
           <a:xfrm>
-            <a:off x="5943600" y="3054858"/>
-            <a:ext cx="2743200" cy="2043684"/>
+            <a:off x="5943600" y="3438906"/>
+            <a:ext cx="2743200" cy="2427732"/>
           </a:xfrm>
           <a:prstGeom prst="rect">
             <a:avLst/>
@@ -12122,7 +12122,7 @@
         </p:nvSpPr>
         <p:spPr>
           <a:xfrm>
-            <a:off x="6108192" y="3182874"/>
+            <a:off x="6108192" y="3566922"/>
             <a:ext cx="2414016" cy="283464"/>
           </a:xfrm>
           <a:prstGeom prst="rect">
@@ -12156,7 +12156,7 @@
         </p:nvSpPr>
         <p:spPr>
           <a:xfrm>
-            <a:off x="6108192" y="3411474"/>
+            <a:off x="6108192" y="3850386"/>
             <a:ext cx="2414016" cy="302513"/>
           </a:xfrm>
           <a:prstGeom prst="rect">
@@ -12190,7 +12190,7 @@
         </p:nvSpPr>
         <p:spPr>
           <a:xfrm>
-            <a:off x="6108192" y="3659123"/>
+            <a:off x="6108192" y="4152899"/>
             <a:ext cx="2414016" cy="302513"/>
           </a:xfrm>
           <a:prstGeom prst="rect">
@@ -12224,7 +12224,7 @@
         </p:nvSpPr>
         <p:spPr>
           <a:xfrm>
-            <a:off x="6108192" y="3906772"/>
+            <a:off x="6108192" y="4455412"/>
             <a:ext cx="2414016" cy="302513"/>
           </a:xfrm>
           <a:prstGeom prst="rect">
@@ -12258,7 +12258,7 @@
         </p:nvSpPr>
         <p:spPr>
           <a:xfrm>
-            <a:off x="6108192" y="4154421"/>
+            <a:off x="6108192" y="4757925"/>
             <a:ext cx="2414016" cy="302513"/>
           </a:xfrm>
           <a:prstGeom prst="rect">
@@ -12292,7 +12292,7 @@
         </p:nvSpPr>
         <p:spPr>
           <a:xfrm>
-            <a:off x="6108192" y="4402070"/>
+            <a:off x="6108192" y="5060438"/>
             <a:ext cx="2414016" cy="302513"/>
           </a:xfrm>
           <a:prstGeom prst="rect">
@@ -12326,7 +12326,7 @@
         </p:nvSpPr>
         <p:spPr>
           <a:xfrm>
-            <a:off x="6108192" y="4649719"/>
+            <a:off x="6108192" y="5362951"/>
             <a:ext cx="2414016" cy="302513"/>
           </a:xfrm>
           <a:prstGeom prst="rect">
@@ -12360,8 +12360,8 @@
         </p:nvSpPr>
         <p:spPr>
           <a:xfrm>
-            <a:off x="8732520" y="3054858"/>
-            <a:ext cx="3108960" cy="2024633"/>
+            <a:off x="8732520" y="3438906"/>
+            <a:ext cx="3108960" cy="2408682"/>
           </a:xfrm>
           <a:prstGeom prst="rect">
             <a:avLst/>
@@ -12403,7 +12403,7 @@
         </p:nvSpPr>
         <p:spPr>
           <a:xfrm>
-            <a:off x="8897112" y="3182874"/>
+            <a:off x="8897112" y="3566922"/>
             <a:ext cx="2779776" cy="283464"/>
           </a:xfrm>
           <a:prstGeom prst="rect">
@@ -12437,7 +12437,7 @@
         </p:nvSpPr>
         <p:spPr>
           <a:xfrm>
-            <a:off x="8897112" y="3411474"/>
+            <a:off x="8897112" y="3850386"/>
             <a:ext cx="2779776" cy="302513"/>
           </a:xfrm>
           <a:prstGeom prst="rect">
@@ -12471,7 +12471,7 @@
         </p:nvSpPr>
         <p:spPr>
           <a:xfrm>
-            <a:off x="8897112" y="3659123"/>
+            <a:off x="8897112" y="4152899"/>
             <a:ext cx="2779776" cy="302513"/>
           </a:xfrm>
           <a:prstGeom prst="rect">
@@ -12505,7 +12505,7 @@
         </p:nvSpPr>
         <p:spPr>
           <a:xfrm>
-            <a:off x="8897112" y="3906772"/>
+            <a:off x="8897112" y="4455412"/>
             <a:ext cx="2779776" cy="302513"/>
           </a:xfrm>
           <a:prstGeom prst="rect">
@@ -12539,7 +12539,7 @@
         </p:nvSpPr>
         <p:spPr>
           <a:xfrm>
-            <a:off x="8897112" y="4154421"/>
+            <a:off x="8897112" y="4757925"/>
             <a:ext cx="2779776" cy="283464"/>
           </a:xfrm>
           <a:prstGeom prst="rect">
@@ -12573,7 +12573,7 @@
         </p:nvSpPr>
         <p:spPr>
           <a:xfrm>
-            <a:off x="8897112" y="4383021"/>
+            <a:off x="8897112" y="5041389"/>
             <a:ext cx="2779776" cy="302513"/>
           </a:xfrm>
           <a:prstGeom prst="rect">
@@ -12607,7 +12607,7 @@
         </p:nvSpPr>
         <p:spPr>
           <a:xfrm>
-            <a:off x="8897112" y="4630670"/>
+            <a:off x="8897112" y="5343902"/>
             <a:ext cx="2779776" cy="302513"/>
           </a:xfrm>
           <a:prstGeom prst="rect">
@@ -12859,7 +12859,7 @@
         <p:spPr>
           <a:xfrm>
             <a:off x="274320" y="749808"/>
-            <a:ext cx="4937760" cy="4005834"/>
+            <a:ext cx="4937760" cy="4828794"/>
           </a:xfrm>
           <a:prstGeom prst="rect">
             <a:avLst/>
@@ -12935,7 +12935,7 @@
         </p:nvSpPr>
         <p:spPr>
           <a:xfrm>
-            <a:off x="438912" y="1106424"/>
+            <a:off x="438912" y="1161288"/>
             <a:ext cx="4608576" cy="302513"/>
           </a:xfrm>
           <a:prstGeom prst="rect">
@@ -12969,7 +12969,7 @@
         </p:nvSpPr>
         <p:spPr>
           <a:xfrm>
-            <a:off x="438912" y="1354073"/>
+            <a:off x="438912" y="1463801"/>
             <a:ext cx="4608576" cy="302513"/>
           </a:xfrm>
           <a:prstGeom prst="rect">
@@ -13003,7 +13003,7 @@
         </p:nvSpPr>
         <p:spPr>
           <a:xfrm>
-            <a:off x="438912" y="1601722"/>
+            <a:off x="438912" y="1766314"/>
             <a:ext cx="4608576" cy="302513"/>
           </a:xfrm>
           <a:prstGeom prst="rect">
@@ -13037,7 +13037,7 @@
         </p:nvSpPr>
         <p:spPr>
           <a:xfrm>
-            <a:off x="438912" y="1849371"/>
+            <a:off x="438912" y="2068827"/>
             <a:ext cx="4608576" cy="302513"/>
           </a:xfrm>
           <a:prstGeom prst="rect">
@@ -13071,7 +13071,7 @@
         </p:nvSpPr>
         <p:spPr>
           <a:xfrm>
-            <a:off x="438912" y="2097020"/>
+            <a:off x="438912" y="2371340"/>
             <a:ext cx="4608576" cy="302513"/>
           </a:xfrm>
           <a:prstGeom prst="rect">
@@ -13105,7 +13105,7 @@
         </p:nvSpPr>
         <p:spPr>
           <a:xfrm>
-            <a:off x="438912" y="2344669"/>
+            <a:off x="438912" y="2673853"/>
             <a:ext cx="4608576" cy="302513"/>
           </a:xfrm>
           <a:prstGeom prst="rect">
@@ -13139,7 +13139,7 @@
         </p:nvSpPr>
         <p:spPr>
           <a:xfrm>
-            <a:off x="438912" y="2592318"/>
+            <a:off x="438912" y="2976366"/>
             <a:ext cx="4608576" cy="302513"/>
           </a:xfrm>
           <a:prstGeom prst="rect">
@@ -13173,7 +13173,7 @@
         </p:nvSpPr>
         <p:spPr>
           <a:xfrm>
-            <a:off x="438912" y="2839967"/>
+            <a:off x="438912" y="3278879"/>
             <a:ext cx="4608576" cy="302513"/>
           </a:xfrm>
           <a:prstGeom prst="rect">
@@ -13207,7 +13207,7 @@
         </p:nvSpPr>
         <p:spPr>
           <a:xfrm>
-            <a:off x="438912" y="3087616"/>
+            <a:off x="438912" y="3581392"/>
             <a:ext cx="4608576" cy="283464"/>
           </a:xfrm>
           <a:prstGeom prst="rect">
@@ -13241,7 +13241,7 @@
         </p:nvSpPr>
         <p:spPr>
           <a:xfrm>
-            <a:off x="438912" y="3316216"/>
+            <a:off x="438912" y="3864856"/>
             <a:ext cx="4608576" cy="302513"/>
           </a:xfrm>
           <a:prstGeom prst="rect">
@@ -13275,7 +13275,7 @@
         </p:nvSpPr>
         <p:spPr>
           <a:xfrm>
-            <a:off x="438912" y="3563865"/>
+            <a:off x="438912" y="4167369"/>
             <a:ext cx="4608576" cy="302513"/>
           </a:xfrm>
           <a:prstGeom prst="rect">
@@ -13309,7 +13309,7 @@
         </p:nvSpPr>
         <p:spPr>
           <a:xfrm>
-            <a:off x="438912" y="3811514"/>
+            <a:off x="438912" y="4469882"/>
             <a:ext cx="4608576" cy="302513"/>
           </a:xfrm>
           <a:prstGeom prst="rect">
@@ -13343,7 +13343,7 @@
         </p:nvSpPr>
         <p:spPr>
           <a:xfrm>
-            <a:off x="438912" y="4059163"/>
+            <a:off x="438912" y="4772395"/>
             <a:ext cx="4608576" cy="302513"/>
           </a:xfrm>
           <a:prstGeom prst="rect">
@@ -13377,7 +13377,7 @@
         </p:nvSpPr>
         <p:spPr>
           <a:xfrm>
-            <a:off x="438912" y="4306812"/>
+            <a:off x="438912" y="5074908"/>
             <a:ext cx="4608576" cy="302513"/>
           </a:xfrm>
           <a:prstGeom prst="rect">
@@ -13412,7 +13412,7 @@
         <p:spPr>
           <a:xfrm>
             <a:off x="5349240" y="749808"/>
-            <a:ext cx="3200400" cy="3739134"/>
+            <a:ext cx="3200400" cy="4507230"/>
           </a:xfrm>
           <a:prstGeom prst="rect">
             <a:avLst/>
@@ -13488,7 +13488,7 @@
         </p:nvSpPr>
         <p:spPr>
           <a:xfrm>
-            <a:off x="5513832" y="1106424"/>
+            <a:off x="5513832" y="1161288"/>
             <a:ext cx="2871216" cy="302513"/>
           </a:xfrm>
           <a:prstGeom prst="rect">
@@ -13522,7 +13522,7 @@
         </p:nvSpPr>
         <p:spPr>
           <a:xfrm>
-            <a:off x="5513832" y="1354073"/>
+            <a:off x="5513832" y="1463801"/>
             <a:ext cx="2871216" cy="302513"/>
           </a:xfrm>
           <a:prstGeom prst="rect">
@@ -13556,7 +13556,7 @@
         </p:nvSpPr>
         <p:spPr>
           <a:xfrm>
-            <a:off x="5513832" y="1601722"/>
+            <a:off x="5513832" y="1766314"/>
             <a:ext cx="2871216" cy="302513"/>
           </a:xfrm>
           <a:prstGeom prst="rect">
@@ -13590,7 +13590,7 @@
         </p:nvSpPr>
         <p:spPr>
           <a:xfrm>
-            <a:off x="5513832" y="1849371"/>
+            <a:off x="5513832" y="2068827"/>
             <a:ext cx="2871216" cy="302513"/>
           </a:xfrm>
           <a:prstGeom prst="rect">
@@ -13624,7 +13624,7 @@
         </p:nvSpPr>
         <p:spPr>
           <a:xfrm>
-            <a:off x="5513832" y="2097020"/>
+            <a:off x="5513832" y="2371340"/>
             <a:ext cx="2871216" cy="302513"/>
           </a:xfrm>
           <a:prstGeom prst="rect">
@@ -13658,7 +13658,7 @@
         </p:nvSpPr>
         <p:spPr>
           <a:xfrm>
-            <a:off x="5513832" y="2344669"/>
+            <a:off x="5513832" y="2673853"/>
             <a:ext cx="2871216" cy="283464"/>
           </a:xfrm>
           <a:prstGeom prst="rect">
@@ -13692,7 +13692,7 @@
         </p:nvSpPr>
         <p:spPr>
           <a:xfrm>
-            <a:off x="5513832" y="2573269"/>
+            <a:off x="5513832" y="2957317"/>
             <a:ext cx="2871216" cy="302513"/>
           </a:xfrm>
           <a:prstGeom prst="rect">
@@ -13726,7 +13726,7 @@
         </p:nvSpPr>
         <p:spPr>
           <a:xfrm>
-            <a:off x="5513832" y="2820918"/>
+            <a:off x="5513832" y="3259830"/>
             <a:ext cx="2871216" cy="302513"/>
           </a:xfrm>
           <a:prstGeom prst="rect">
@@ -13760,7 +13760,7 @@
         </p:nvSpPr>
         <p:spPr>
           <a:xfrm>
-            <a:off x="5513832" y="3068567"/>
+            <a:off x="5513832" y="3562343"/>
             <a:ext cx="2871216" cy="283464"/>
           </a:xfrm>
           <a:prstGeom prst="rect">
@@ -13794,7 +13794,7 @@
         </p:nvSpPr>
         <p:spPr>
           <a:xfrm>
-            <a:off x="5513832" y="3297167"/>
+            <a:off x="5513832" y="3845807"/>
             <a:ext cx="2871216" cy="302513"/>
           </a:xfrm>
           <a:prstGeom prst="rect">
@@ -13828,7 +13828,7 @@
         </p:nvSpPr>
         <p:spPr>
           <a:xfrm>
-            <a:off x="5513832" y="3544816"/>
+            <a:off x="5513832" y="4148320"/>
             <a:ext cx="2871216" cy="302513"/>
           </a:xfrm>
           <a:prstGeom prst="rect">
@@ -13862,7 +13862,7 @@
         </p:nvSpPr>
         <p:spPr>
           <a:xfrm>
-            <a:off x="5513832" y="3792465"/>
+            <a:off x="5513832" y="4450833"/>
             <a:ext cx="2871216" cy="302513"/>
           </a:xfrm>
           <a:prstGeom prst="rect">
@@ -13896,7 +13896,7 @@
         </p:nvSpPr>
         <p:spPr>
           <a:xfrm>
-            <a:off x="5513832" y="4040114"/>
+            <a:off x="5513832" y="4753346"/>
             <a:ext cx="2871216" cy="302513"/>
           </a:xfrm>
           <a:prstGeom prst="rect">
@@ -14093,7 +14093,7 @@
         <p:spPr>
           <a:xfrm>
             <a:off x="274320" y="749808"/>
-            <a:ext cx="4937760" cy="3491483"/>
+            <a:ext cx="4937760" cy="4149851"/>
           </a:xfrm>
           <a:prstGeom prst="rect">
             <a:avLst/>
@@ -14169,7 +14169,7 @@
         </p:nvSpPr>
         <p:spPr>
           <a:xfrm>
-            <a:off x="438912" y="1125473"/>
+            <a:off x="438912" y="1180337"/>
             <a:ext cx="4608576" cy="321564"/>
           </a:xfrm>
           <a:prstGeom prst="rect">
@@ -14203,7 +14203,7 @@
         </p:nvSpPr>
         <p:spPr>
           <a:xfrm>
-            <a:off x="438912" y="1392173"/>
+            <a:off x="438912" y="1501901"/>
             <a:ext cx="4608576" cy="321564"/>
           </a:xfrm>
           <a:prstGeom prst="rect">
@@ -14237,7 +14237,7 @@
         </p:nvSpPr>
         <p:spPr>
           <a:xfrm>
-            <a:off x="438912" y="1658873"/>
+            <a:off x="438912" y="1823465"/>
             <a:ext cx="4608576" cy="321564"/>
           </a:xfrm>
           <a:prstGeom prst="rect">
@@ -14271,7 +14271,7 @@
         </p:nvSpPr>
         <p:spPr>
           <a:xfrm>
-            <a:off x="438912" y="1925573"/>
+            <a:off x="438912" y="2145029"/>
             <a:ext cx="4608576" cy="321564"/>
           </a:xfrm>
           <a:prstGeom prst="rect">
@@ -14305,7 +14305,7 @@
         </p:nvSpPr>
         <p:spPr>
           <a:xfrm>
-            <a:off x="438912" y="2192273"/>
+            <a:off x="438912" y="2466593"/>
             <a:ext cx="4608576" cy="302513"/>
           </a:xfrm>
           <a:prstGeom prst="rect">
@@ -14339,7 +14339,7 @@
         </p:nvSpPr>
         <p:spPr>
           <a:xfrm>
-            <a:off x="438912" y="2439922"/>
+            <a:off x="438912" y="2769106"/>
             <a:ext cx="4608576" cy="321564"/>
           </a:xfrm>
           <a:prstGeom prst="rect">
@@ -14373,7 +14373,7 @@
         </p:nvSpPr>
         <p:spPr>
           <a:xfrm>
-            <a:off x="438912" y="2706622"/>
+            <a:off x="438912" y="3090670"/>
             <a:ext cx="4608576" cy="321564"/>
           </a:xfrm>
           <a:prstGeom prst="rect">
@@ -14407,7 +14407,7 @@
         </p:nvSpPr>
         <p:spPr>
           <a:xfrm>
-            <a:off x="438912" y="2973322"/>
+            <a:off x="438912" y="3412234"/>
             <a:ext cx="4608576" cy="321564"/>
           </a:xfrm>
           <a:prstGeom prst="rect">
@@ -14441,7 +14441,7 @@
         </p:nvSpPr>
         <p:spPr>
           <a:xfrm>
-            <a:off x="438912" y="3240022"/>
+            <a:off x="438912" y="3733798"/>
             <a:ext cx="4608576" cy="321564"/>
           </a:xfrm>
           <a:prstGeom prst="rect">
@@ -14475,7 +14475,7 @@
         </p:nvSpPr>
         <p:spPr>
           <a:xfrm>
-            <a:off x="438912" y="3506722"/>
+            <a:off x="438912" y="4055362"/>
             <a:ext cx="4608576" cy="321564"/>
           </a:xfrm>
           <a:prstGeom prst="rect">
@@ -14509,7 +14509,7 @@
         </p:nvSpPr>
         <p:spPr>
           <a:xfrm>
-            <a:off x="438912" y="3773422"/>
+            <a:off x="438912" y="4376926"/>
             <a:ext cx="4608576" cy="321564"/>
           </a:xfrm>
           <a:prstGeom prst="rect">
@@ -14544,7 +14544,7 @@
         <p:spPr>
           <a:xfrm>
             <a:off x="5349240" y="749808"/>
-            <a:ext cx="3200400" cy="2824733"/>
+            <a:ext cx="3200400" cy="3318510"/>
           </a:xfrm>
           <a:prstGeom prst="rect">
             <a:avLst/>
@@ -14620,7 +14620,7 @@
         </p:nvSpPr>
         <p:spPr>
           <a:xfrm>
-            <a:off x="5513832" y="1125473"/>
+            <a:off x="5513832" y="1180337"/>
             <a:ext cx="2871216" cy="321564"/>
           </a:xfrm>
           <a:prstGeom prst="rect">
@@ -14654,7 +14654,7 @@
         </p:nvSpPr>
         <p:spPr>
           <a:xfrm>
-            <a:off x="5513832" y="1392173"/>
+            <a:off x="5513832" y="1501901"/>
             <a:ext cx="2871216" cy="321564"/>
           </a:xfrm>
           <a:prstGeom prst="rect">
@@ -14688,7 +14688,7 @@
         </p:nvSpPr>
         <p:spPr>
           <a:xfrm>
-            <a:off x="5513832" y="1658873"/>
+            <a:off x="5513832" y="1823465"/>
             <a:ext cx="2871216" cy="321564"/>
           </a:xfrm>
           <a:prstGeom prst="rect">
@@ -14722,7 +14722,7 @@
         </p:nvSpPr>
         <p:spPr>
           <a:xfrm>
-            <a:off x="5513832" y="2058923"/>
+            <a:off x="5513832" y="2278379"/>
             <a:ext cx="2871216" cy="302513"/>
           </a:xfrm>
           <a:prstGeom prst="rect">
@@ -14756,7 +14756,7 @@
         </p:nvSpPr>
         <p:spPr>
           <a:xfrm>
-            <a:off x="5513832" y="2306572"/>
+            <a:off x="5513832" y="2580892"/>
             <a:ext cx="2871216" cy="321564"/>
           </a:xfrm>
           <a:prstGeom prst="rect">
@@ -14790,7 +14790,7 @@
         </p:nvSpPr>
         <p:spPr>
           <a:xfrm>
-            <a:off x="5513832" y="2573272"/>
+            <a:off x="5513832" y="2902456"/>
             <a:ext cx="2871216" cy="321564"/>
           </a:xfrm>
           <a:prstGeom prst="rect">
@@ -14824,7 +14824,7 @@
         </p:nvSpPr>
         <p:spPr>
           <a:xfrm>
-            <a:off x="5513832" y="2839972"/>
+            <a:off x="5513832" y="3224020"/>
             <a:ext cx="2871216" cy="321564"/>
           </a:xfrm>
           <a:prstGeom prst="rect">
@@ -14858,7 +14858,7 @@
         </p:nvSpPr>
         <p:spPr>
           <a:xfrm>
-            <a:off x="5513832" y="3106672"/>
+            <a:off x="5513832" y="3545584"/>
             <a:ext cx="2871216" cy="321564"/>
           </a:xfrm>
           <a:prstGeom prst="rect">
@@ -14892,8 +14892,8 @@
         </p:nvSpPr>
         <p:spPr>
           <a:xfrm>
-            <a:off x="274320" y="4369307"/>
-            <a:ext cx="8229600" cy="1300734"/>
+            <a:off x="274320" y="5027675"/>
+            <a:ext cx="8229600" cy="1520190"/>
           </a:xfrm>
           <a:prstGeom prst="rect">
             <a:avLst/>
@@ -14935,7 +14935,7 @@
         </p:nvSpPr>
         <p:spPr>
           <a:xfrm>
-            <a:off x="438912" y="4497323"/>
+            <a:off x="438912" y="5155691"/>
             <a:ext cx="7900416" cy="283464"/>
           </a:xfrm>
           <a:prstGeom prst="rect">
@@ -14969,7 +14969,7 @@
         </p:nvSpPr>
         <p:spPr>
           <a:xfrm>
-            <a:off x="438912" y="4725923"/>
+            <a:off x="438912" y="5439155"/>
             <a:ext cx="7900416" cy="302513"/>
           </a:xfrm>
           <a:prstGeom prst="rect">
@@ -15003,7 +15003,7 @@
         </p:nvSpPr>
         <p:spPr>
           <a:xfrm>
-            <a:off x="438912" y="4973572"/>
+            <a:off x="438912" y="5741668"/>
             <a:ext cx="7900416" cy="302513"/>
           </a:xfrm>
           <a:prstGeom prst="rect">
@@ -15037,7 +15037,7 @@
         </p:nvSpPr>
         <p:spPr>
           <a:xfrm>
-            <a:off x="438912" y="5221221"/>
+            <a:off x="438912" y="6044181"/>
             <a:ext cx="7900416" cy="302513"/>
           </a:xfrm>
           <a:prstGeom prst="rect">
@@ -15210,7 +15210,7 @@
         <p:spPr>
           <a:xfrm>
             <a:off x="274320" y="749808"/>
-            <a:ext cx="3749039" cy="2424684"/>
+            <a:ext cx="3749039" cy="2863596"/>
           </a:xfrm>
           <a:prstGeom prst="rect">
             <a:avLst/>
@@ -15286,7 +15286,7 @@
         </p:nvSpPr>
         <p:spPr>
           <a:xfrm>
-            <a:off x="438912" y="1125473"/>
+            <a:off x="438912" y="1180337"/>
             <a:ext cx="3419855" cy="321564"/>
           </a:xfrm>
           <a:prstGeom prst="rect">
@@ -15320,7 +15320,7 @@
         </p:nvSpPr>
         <p:spPr>
           <a:xfrm>
-            <a:off x="438912" y="1392173"/>
+            <a:off x="438912" y="1501901"/>
             <a:ext cx="3419855" cy="321564"/>
           </a:xfrm>
           <a:prstGeom prst="rect">
@@ -15354,7 +15354,7 @@
         </p:nvSpPr>
         <p:spPr>
           <a:xfrm>
-            <a:off x="438912" y="1658873"/>
+            <a:off x="438912" y="1823465"/>
             <a:ext cx="3419855" cy="321564"/>
           </a:xfrm>
           <a:prstGeom prst="rect">
@@ -15388,7 +15388,7 @@
         </p:nvSpPr>
         <p:spPr>
           <a:xfrm>
-            <a:off x="438912" y="1925573"/>
+            <a:off x="438912" y="2145029"/>
             <a:ext cx="3419855" cy="302513"/>
           </a:xfrm>
           <a:prstGeom prst="rect">
@@ -15422,7 +15422,7 @@
         </p:nvSpPr>
         <p:spPr>
           <a:xfrm>
-            <a:off x="438912" y="2173222"/>
+            <a:off x="438912" y="2447542"/>
             <a:ext cx="3419855" cy="321564"/>
           </a:xfrm>
           <a:prstGeom prst="rect">
@@ -15456,7 +15456,7 @@
         </p:nvSpPr>
         <p:spPr>
           <a:xfrm>
-            <a:off x="438912" y="2439922"/>
+            <a:off x="438912" y="2769106"/>
             <a:ext cx="3419855" cy="321564"/>
           </a:xfrm>
           <a:prstGeom prst="rect">
@@ -15490,7 +15490,7 @@
         </p:nvSpPr>
         <p:spPr>
           <a:xfrm>
-            <a:off x="438912" y="2706622"/>
+            <a:off x="438912" y="3090670"/>
             <a:ext cx="3419855" cy="321564"/>
           </a:xfrm>
           <a:prstGeom prst="rect">
@@ -15525,7 +15525,7 @@
         <p:spPr>
           <a:xfrm>
             <a:off x="4160520" y="749808"/>
-            <a:ext cx="3749039" cy="2691384"/>
+            <a:ext cx="3749039" cy="3185159"/>
           </a:xfrm>
           <a:prstGeom prst="rect">
             <a:avLst/>
@@ -15601,7 +15601,7 @@
         </p:nvSpPr>
         <p:spPr>
           <a:xfrm>
-            <a:off x="4325112" y="1125473"/>
+            <a:off x="4325112" y="1180337"/>
             <a:ext cx="3419855" cy="321564"/>
           </a:xfrm>
           <a:prstGeom prst="rect">
@@ -15635,7 +15635,7 @@
         </p:nvSpPr>
         <p:spPr>
           <a:xfrm>
-            <a:off x="4325112" y="1392173"/>
+            <a:off x="4325112" y="1501901"/>
             <a:ext cx="3419855" cy="321564"/>
           </a:xfrm>
           <a:prstGeom prst="rect">
@@ -15669,7 +15669,7 @@
         </p:nvSpPr>
         <p:spPr>
           <a:xfrm>
-            <a:off x="4325112" y="1658873"/>
+            <a:off x="4325112" y="1823465"/>
             <a:ext cx="3419855" cy="321564"/>
           </a:xfrm>
           <a:prstGeom prst="rect">
@@ -15703,7 +15703,7 @@
         </p:nvSpPr>
         <p:spPr>
           <a:xfrm>
-            <a:off x="4325112" y="1925573"/>
+            <a:off x="4325112" y="2145029"/>
             <a:ext cx="3419855" cy="321564"/>
           </a:xfrm>
           <a:prstGeom prst="rect">
@@ -15737,7 +15737,7 @@
         </p:nvSpPr>
         <p:spPr>
           <a:xfrm>
-            <a:off x="4325112" y="2192273"/>
+            <a:off x="4325112" y="2466593"/>
             <a:ext cx="3419855" cy="321564"/>
           </a:xfrm>
           <a:prstGeom prst="rect">
@@ -15771,7 +15771,7 @@
         </p:nvSpPr>
         <p:spPr>
           <a:xfrm>
-            <a:off x="4325112" y="2458973"/>
+            <a:off x="4325112" y="2788157"/>
             <a:ext cx="3419855" cy="302513"/>
           </a:xfrm>
           <a:prstGeom prst="rect">
@@ -15805,7 +15805,7 @@
         </p:nvSpPr>
         <p:spPr>
           <a:xfrm>
-            <a:off x="4325112" y="2706622"/>
+            <a:off x="4325112" y="3090670"/>
             <a:ext cx="3419855" cy="321564"/>
           </a:xfrm>
           <a:prstGeom prst="rect">
@@ -15839,7 +15839,7 @@
         </p:nvSpPr>
         <p:spPr>
           <a:xfrm>
-            <a:off x="4325112" y="2973322"/>
+            <a:off x="4325112" y="3412234"/>
             <a:ext cx="3419855" cy="321564"/>
           </a:xfrm>
           <a:prstGeom prst="rect">
@@ -15874,7 +15874,7 @@
         <p:spPr>
           <a:xfrm>
             <a:off x="8046720" y="749808"/>
-            <a:ext cx="3840480" cy="2157984"/>
+            <a:ext cx="3840480" cy="2542032"/>
           </a:xfrm>
           <a:prstGeom prst="rect">
             <a:avLst/>
@@ -15950,7 +15950,7 @@
         </p:nvSpPr>
         <p:spPr>
           <a:xfrm>
-            <a:off x="8211312" y="1125473"/>
+            <a:off x="8211312" y="1180337"/>
             <a:ext cx="3511296" cy="321564"/>
           </a:xfrm>
           <a:prstGeom prst="rect">
@@ -15984,7 +15984,7 @@
         </p:nvSpPr>
         <p:spPr>
           <a:xfrm>
-            <a:off x="8211312" y="1392173"/>
+            <a:off x="8211312" y="1501901"/>
             <a:ext cx="3511296" cy="321564"/>
           </a:xfrm>
           <a:prstGeom prst="rect">
@@ -16018,7 +16018,7 @@
         </p:nvSpPr>
         <p:spPr>
           <a:xfrm>
-            <a:off x="8211312" y="1658873"/>
+            <a:off x="8211312" y="1823465"/>
             <a:ext cx="3511296" cy="321564"/>
           </a:xfrm>
           <a:prstGeom prst="rect">
@@ -16052,7 +16052,7 @@
         </p:nvSpPr>
         <p:spPr>
           <a:xfrm>
-            <a:off x="8211312" y="1925573"/>
+            <a:off x="8211312" y="2145029"/>
             <a:ext cx="3511296" cy="321564"/>
           </a:xfrm>
           <a:prstGeom prst="rect">
@@ -16086,7 +16086,7 @@
         </p:nvSpPr>
         <p:spPr>
           <a:xfrm>
-            <a:off x="8211312" y="2192273"/>
+            <a:off x="8211312" y="2466593"/>
             <a:ext cx="3511296" cy="302513"/>
           </a:xfrm>
           <a:prstGeom prst="rect">
@@ -16120,7 +16120,7 @@
         </p:nvSpPr>
         <p:spPr>
           <a:xfrm>
-            <a:off x="8211312" y="2439922"/>
+            <a:off x="8211312" y="2769106"/>
             <a:ext cx="3511296" cy="321564"/>
           </a:xfrm>
           <a:prstGeom prst="rect">
@@ -16154,8 +16154,8 @@
         </p:nvSpPr>
         <p:spPr>
           <a:xfrm>
-            <a:off x="274320" y="3569208"/>
-            <a:ext cx="3749039" cy="1110234"/>
+            <a:off x="274320" y="4062983"/>
+            <a:ext cx="3749039" cy="1274826"/>
           </a:xfrm>
           <a:prstGeom prst="rect">
             <a:avLst/>
@@ -16197,7 +16197,7 @@
         </p:nvSpPr>
         <p:spPr>
           <a:xfrm>
-            <a:off x="438912" y="3697224"/>
+            <a:off x="438912" y="4190999"/>
             <a:ext cx="3419855" cy="302513"/>
           </a:xfrm>
           <a:prstGeom prst="rect">
@@ -16231,7 +16231,7 @@
         </p:nvSpPr>
         <p:spPr>
           <a:xfrm>
-            <a:off x="438912" y="3944873"/>
+            <a:off x="438912" y="4493512"/>
             <a:ext cx="3419855" cy="321564"/>
           </a:xfrm>
           <a:prstGeom prst="rect">
@@ -16265,7 +16265,7 @@
         </p:nvSpPr>
         <p:spPr>
           <a:xfrm>
-            <a:off x="438912" y="4211573"/>
+            <a:off x="438912" y="4815076"/>
             <a:ext cx="3419855" cy="321564"/>
           </a:xfrm>
           <a:prstGeom prst="rect">
@@ -16299,8 +16299,8 @@
         </p:nvSpPr>
         <p:spPr>
           <a:xfrm>
-            <a:off x="4160520" y="3569208"/>
-            <a:ext cx="3749039" cy="1376934"/>
+            <a:off x="4160520" y="4062983"/>
+            <a:ext cx="3749039" cy="1596390"/>
           </a:xfrm>
           <a:prstGeom prst="rect">
             <a:avLst/>
@@ -16342,7 +16342,7 @@
         </p:nvSpPr>
         <p:spPr>
           <a:xfrm>
-            <a:off x="4325112" y="3697224"/>
+            <a:off x="4325112" y="4190999"/>
             <a:ext cx="3419855" cy="302513"/>
           </a:xfrm>
           <a:prstGeom prst="rect">
@@ -16376,7 +16376,7 @@
         </p:nvSpPr>
         <p:spPr>
           <a:xfrm>
-            <a:off x="4325112" y="3944873"/>
+            <a:off x="4325112" y="4493512"/>
             <a:ext cx="3419855" cy="321564"/>
           </a:xfrm>
           <a:prstGeom prst="rect">
@@ -16410,7 +16410,7 @@
         </p:nvSpPr>
         <p:spPr>
           <a:xfrm>
-            <a:off x="4325112" y="4211573"/>
+            <a:off x="4325112" y="4815076"/>
             <a:ext cx="3419855" cy="321564"/>
           </a:xfrm>
           <a:prstGeom prst="rect">
@@ -16444,7 +16444,7 @@
         </p:nvSpPr>
         <p:spPr>
           <a:xfrm>
-            <a:off x="4325112" y="4478273"/>
+            <a:off x="4325112" y="5136640"/>
             <a:ext cx="3419855" cy="321564"/>
           </a:xfrm>
           <a:prstGeom prst="rect">
@@ -16478,8 +16478,8 @@
         </p:nvSpPr>
         <p:spPr>
           <a:xfrm>
-            <a:off x="8046720" y="3569208"/>
-            <a:ext cx="3840480" cy="1376934"/>
+            <a:off x="8046720" y="4062983"/>
+            <a:ext cx="3840480" cy="1596390"/>
           </a:xfrm>
           <a:prstGeom prst="rect">
             <a:avLst/>
@@ -16521,7 +16521,7 @@
         </p:nvSpPr>
         <p:spPr>
           <a:xfrm>
-            <a:off x="8211312" y="3697224"/>
+            <a:off x="8211312" y="4190999"/>
             <a:ext cx="3511296" cy="302513"/>
           </a:xfrm>
           <a:prstGeom prst="rect">
@@ -16555,7 +16555,7 @@
         </p:nvSpPr>
         <p:spPr>
           <a:xfrm>
-            <a:off x="8211312" y="3944873"/>
+            <a:off x="8211312" y="4493512"/>
             <a:ext cx="3511296" cy="321564"/>
           </a:xfrm>
           <a:prstGeom prst="rect">
@@ -16589,7 +16589,7 @@
         </p:nvSpPr>
         <p:spPr>
           <a:xfrm>
-            <a:off x="8211312" y="4211573"/>
+            <a:off x="8211312" y="4815076"/>
             <a:ext cx="3511296" cy="321564"/>
           </a:xfrm>
           <a:prstGeom prst="rect">
@@ -16623,7 +16623,7 @@
         </p:nvSpPr>
         <p:spPr>
           <a:xfrm>
-            <a:off x="8211312" y="4478273"/>
+            <a:off x="8211312" y="5136640"/>
             <a:ext cx="3511296" cy="321564"/>
           </a:xfrm>
           <a:prstGeom prst="rect">

</xml_diff>

<commit_message>
hardware: replace discrete TRIAC+igniter relay with Hipzeepo 2-ch AC dimmer module
- config.h: remove PIN_RELAY_IGNITER/PIN_TRIAC, add PIN_DIM_BLOWER (GPIO33) and PIN_DIM_IGNITER (GPIO26)
- wiring.md: full update — 2-ch dimmer section, 2 relays only, parts list updated (snubber components removed)
- CLAUDE.md: update hardware table to reflect 2-ch dimmer module
- make_pptx.py: slide 2 GPIO list, slide 6 (relays, feeder+pump only), slide 7 (TRIAC→dimmer module), slides 9+10 updated
- Regenerated Pellet_Burner_Components.pptx

Co-Authored-By: Claude Sonnet 4.6 <noreply@anthropic.com>
</commit_message>
<xml_diff>
--- a/docs/Pellet_Burner_Components.pptx
+++ b/docs/Pellet_Burner_Components.pptx
@@ -3323,7 +3323,7 @@
                   <a:srgbClr val="AAAAAA"/>
                 </a:solidFill>
               </a:rPr>
-              <a:t>ESP32  ·  SH1106 OLED  ·  DS18B20  ·  MAX6675  ·  Relays  ·  TRIAC  ·  Buttons</a:t>
+              <a:t>ESP32  ·  SH1106 OLED  ·  DS18B20  ·  MAX6675  ·  Relays  ·  AC Dimmer  ·  Buttons</a:t>
             </a:r>
           </a:p>
         </p:txBody>
@@ -4880,7 +4880,7 @@
                             <a:srgbClr val="FFFFFF"/>
                           </a:solidFill>
                         </a:rPr>
-                        <a:t>Relay — Igniter IN</a:t>
+                        <a:t>Dimmer CH2 — Igniter</a:t>
                       </a:r>
                     </a:p>
                   </a:txBody>
@@ -4948,7 +4948,7 @@
                             <a:srgbClr val="FFFFFF"/>
                           </a:solidFill>
                         </a:rPr>
-                        <a:t>GPIO</a:t>
+                        <a:t>PWM</a:t>
                       </a:r>
                     </a:p>
                   </a:txBody>
@@ -5016,7 +5016,7 @@
                             <a:srgbClr val="AAAAAA"/>
                           </a:solidFill>
                         </a:rPr>
-                        <a:t>active LOW, relay VCC = 5 V</a:t>
+                        <a:t>DIM2 on 2-ch AC dimmer module</a:t>
                       </a:r>
                     </a:p>
                   </a:txBody>
@@ -5224,7 +5224,7 @@
                             <a:srgbClr val="FFFFFF"/>
                           </a:solidFill>
                         </a:rPr>
-                        <a:t>TRIAC gate</a:t>
+                        <a:t>Dimmer CH1 — Blower</a:t>
                       </a:r>
                     </a:p>
                   </a:txBody>
@@ -5292,7 +5292,7 @@
                             <a:srgbClr val="FFFFFF"/>
                           </a:solidFill>
                         </a:rPr>
-                        <a:t>GPIO</a:t>
+                        <a:t>PWM</a:t>
                       </a:r>
                     </a:p>
                   </a:txBody>
@@ -5360,7 +5360,7 @@
                             <a:srgbClr val="AAAAAA"/>
                           </a:solidFill>
                         </a:rPr>
-                        <a:t>330 Ω → MOC3021 → TRIAC gate</a:t>
+                        <a:t>DIM1 on 2-ch AC dimmer module</a:t>
                       </a:r>
                     </a:p>
                   </a:txBody>
@@ -6477,7 +6477,7 @@
                   <a:srgbClr val="FFFFFF"/>
                 </a:solidFill>
               </a:rPr>
-              <a:t>• Controls relays and TRIAC output</a:t>
+              <a:t>• Controls relays and AC dimmer module</a:t>
             </a:r>
           </a:p>
         </p:txBody>
@@ -7141,7 +7141,7 @@
                   <a:srgbClr val="FFFFFF"/>
                 </a:solidFill>
               </a:rPr>
-              <a:t>• GPIO26  Relay — Igniter</a:t>
+              <a:t>• GPIO26  Dimmer CH2 — Igniter</a:t>
             </a:r>
           </a:p>
         </p:txBody>
@@ -7209,7 +7209,7 @@
                   <a:srgbClr val="FFFFFF"/>
                 </a:solidFill>
               </a:rPr>
-              <a:t>• GPIO33  TRIAC gate trigger</a:t>
+              <a:t>• GPIO33  Dimmer CH1 — Blower</a:t>
             </a:r>
           </a:p>
         </p:txBody>
@@ -11156,7 +11156,7 @@
                   <a:srgbClr val="E94560"/>
                 </a:solidFill>
               </a:rPr>
-              <a:t>5V Relay Modules  —  Feeder / Igniter / Pump</a:t>
+              <a:t>5V Relay Modules  —  Feeder / Pump</a:t>
             </a:r>
           </a:p>
         </p:txBody>
@@ -11237,7 +11237,7 @@
         <p:spPr>
           <a:xfrm>
             <a:off x="274320" y="749808"/>
-            <a:ext cx="4937760" cy="2561082"/>
+            <a:ext cx="4937760" cy="3506723"/>
           </a:xfrm>
           <a:prstGeom prst="rect">
             <a:avLst/>
@@ -11511,13 +11511,115 @@
       </p:sp>
       <p:sp>
         <p:nvSpPr>
-          <p:cNvPr id="14" name="Rectangle 13"/>
+          <p:cNvPr id="14" name="TextBox 13"/>
+          <p:cNvSpPr txBox="1"/>
+          <p:nvPr/>
+        </p:nvSpPr>
+        <p:spPr>
+          <a:xfrm>
+            <a:off x="438912" y="3109721"/>
+            <a:ext cx="4608576" cy="302513"/>
+          </a:xfrm>
+          <a:prstGeom prst="rect">
+            <a:avLst/>
+          </a:prstGeom>
+          <a:noFill/>
+        </p:spPr>
+        <p:txBody>
+          <a:bodyPr wrap="square">
+            <a:spAutoFit/>
+          </a:bodyPr>
+          <a:lstStyle/>
+          <a:p>
+            <a:pPr algn="l"/>
+            <a:r>
+              <a:rPr sz="1300" b="1">
+                <a:solidFill>
+                  <a:srgbClr val="A8DADC"/>
+                </a:solidFill>
+              </a:rPr>
+              <a:t>Note</a:t>
+            </a:r>
+          </a:p>
+        </p:txBody>
+      </p:sp>
+      <p:sp>
+        <p:nvSpPr>
+          <p:cNvPr id="15" name="TextBox 14"/>
+          <p:cNvSpPr txBox="1"/>
+          <p:nvPr/>
+        </p:nvSpPr>
+        <p:spPr>
+          <a:xfrm>
+            <a:off x="438912" y="3412234"/>
+            <a:ext cx="4608576" cy="321564"/>
+          </a:xfrm>
+          <a:prstGeom prst="rect">
+            <a:avLst/>
+          </a:prstGeom>
+          <a:noFill/>
+        </p:spPr>
+        <p:txBody>
+          <a:bodyPr wrap="square">
+            <a:spAutoFit/>
+          </a:bodyPr>
+          <a:lstStyle/>
+          <a:p>
+            <a:pPr algn="l"/>
+            <a:r>
+              <a:rPr sz="1400" b="0">
+                <a:solidFill>
+                  <a:srgbClr val="FFFFFF"/>
+                </a:solidFill>
+              </a:rPr>
+              <a:t>• Igniter is now on AC dimmer CH2 — not a relay.</a:t>
+            </a:r>
+          </a:p>
+        </p:txBody>
+      </p:sp>
+      <p:sp>
+        <p:nvSpPr>
+          <p:cNvPr id="16" name="TextBox 15"/>
+          <p:cNvSpPr txBox="1"/>
+          <p:nvPr/>
+        </p:nvSpPr>
+        <p:spPr>
+          <a:xfrm>
+            <a:off x="438912" y="3733798"/>
+            <a:ext cx="4608576" cy="321564"/>
+          </a:xfrm>
+          <a:prstGeom prst="rect">
+            <a:avLst/>
+          </a:prstGeom>
+          <a:noFill/>
+        </p:spPr>
+        <p:txBody>
+          <a:bodyPr wrap="square">
+            <a:spAutoFit/>
+          </a:bodyPr>
+          <a:lstStyle/>
+          <a:p>
+            <a:pPr algn="l"/>
+            <a:r>
+              <a:rPr sz="1400" b="0">
+                <a:solidFill>
+                  <a:srgbClr val="FFFFFF"/>
+                </a:solidFill>
+              </a:rPr>
+              <a:t>• Only 2 relay modules needed for this build.</a:t>
+            </a:r>
+          </a:p>
+        </p:txBody>
+      </p:sp>
+      <p:sp>
+        <p:nvSpPr>
+          <p:cNvPr id="17" name="Rectangle 16"/>
           <p:cNvSpPr/>
           <p:nvPr/>
         </p:nvSpPr>
         <p:spPr>
           <a:xfrm>
-            <a:off x="274320" y="3438906"/>
+            <a:off x="274320" y="4384547"/>
             <a:ext cx="2743200" cy="2427732"/>
           </a:xfrm>
           <a:prstGeom prst="rect">
@@ -11554,13 +11656,13 @@
       </p:sp>
       <p:sp>
         <p:nvSpPr>
-          <p:cNvPr id="15" name="TextBox 14"/>
-          <p:cNvSpPr txBox="1"/>
-          <p:nvPr/>
-        </p:nvSpPr>
-        <p:spPr>
-          <a:xfrm>
-            <a:off x="438912" y="3566922"/>
+          <p:cNvPr id="18" name="TextBox 17"/>
+          <p:cNvSpPr txBox="1"/>
+          <p:nvPr/>
+        </p:nvSpPr>
+        <p:spPr>
+          <a:xfrm>
+            <a:off x="438912" y="4512563"/>
             <a:ext cx="2414016" cy="283464"/>
           </a:xfrm>
           <a:prstGeom prst="rect">
@@ -11588,13 +11690,13 @@
       </p:sp>
       <p:sp>
         <p:nvSpPr>
-          <p:cNvPr id="16" name="TextBox 15"/>
-          <p:cNvSpPr txBox="1"/>
-          <p:nvPr/>
-        </p:nvSpPr>
-        <p:spPr>
-          <a:xfrm>
-            <a:off x="438912" y="3850386"/>
+          <p:cNvPr id="19" name="TextBox 18"/>
+          <p:cNvSpPr txBox="1"/>
+          <p:nvPr/>
+        </p:nvSpPr>
+        <p:spPr>
+          <a:xfrm>
+            <a:off x="438912" y="4796027"/>
             <a:ext cx="2414016" cy="302513"/>
           </a:xfrm>
           <a:prstGeom prst="rect">
@@ -11622,13 +11724,13 @@
       </p:sp>
       <p:sp>
         <p:nvSpPr>
-          <p:cNvPr id="17" name="TextBox 16"/>
-          <p:cNvSpPr txBox="1"/>
-          <p:nvPr/>
-        </p:nvSpPr>
-        <p:spPr>
-          <a:xfrm>
-            <a:off x="438912" y="4152899"/>
+          <p:cNvPr id="20" name="TextBox 19"/>
+          <p:cNvSpPr txBox="1"/>
+          <p:nvPr/>
+        </p:nvSpPr>
+        <p:spPr>
+          <a:xfrm>
+            <a:off x="438912" y="5098540"/>
             <a:ext cx="2414016" cy="302513"/>
           </a:xfrm>
           <a:prstGeom prst="rect">
@@ -11656,13 +11758,13 @@
       </p:sp>
       <p:sp>
         <p:nvSpPr>
-          <p:cNvPr id="18" name="TextBox 17"/>
-          <p:cNvSpPr txBox="1"/>
-          <p:nvPr/>
-        </p:nvSpPr>
-        <p:spPr>
-          <a:xfrm>
-            <a:off x="438912" y="4455412"/>
+          <p:cNvPr id="21" name="TextBox 20"/>
+          <p:cNvSpPr txBox="1"/>
+          <p:nvPr/>
+        </p:nvSpPr>
+        <p:spPr>
+          <a:xfrm>
+            <a:off x="438912" y="5401053"/>
             <a:ext cx="2414016" cy="302513"/>
           </a:xfrm>
           <a:prstGeom prst="rect">
@@ -11690,13 +11792,13 @@
       </p:sp>
       <p:sp>
         <p:nvSpPr>
-          <p:cNvPr id="19" name="TextBox 18"/>
-          <p:cNvSpPr txBox="1"/>
-          <p:nvPr/>
-        </p:nvSpPr>
-        <p:spPr>
-          <a:xfrm>
-            <a:off x="438912" y="4757925"/>
+          <p:cNvPr id="22" name="TextBox 21"/>
+          <p:cNvSpPr txBox="1"/>
+          <p:nvPr/>
+        </p:nvSpPr>
+        <p:spPr>
+          <a:xfrm>
+            <a:off x="438912" y="5703566"/>
             <a:ext cx="2414016" cy="302513"/>
           </a:xfrm>
           <a:prstGeom prst="rect">
@@ -11724,13 +11826,13 @@
       </p:sp>
       <p:sp>
         <p:nvSpPr>
-          <p:cNvPr id="20" name="TextBox 19"/>
-          <p:cNvSpPr txBox="1"/>
-          <p:nvPr/>
-        </p:nvSpPr>
-        <p:spPr>
-          <a:xfrm>
-            <a:off x="438912" y="5060438"/>
+          <p:cNvPr id="23" name="TextBox 22"/>
+          <p:cNvSpPr txBox="1"/>
+          <p:nvPr/>
+        </p:nvSpPr>
+        <p:spPr>
+          <a:xfrm>
+            <a:off x="438912" y="6006079"/>
             <a:ext cx="2414016" cy="302513"/>
           </a:xfrm>
           <a:prstGeom prst="rect">
@@ -11758,13 +11860,13 @@
       </p:sp>
       <p:sp>
         <p:nvSpPr>
-          <p:cNvPr id="21" name="TextBox 20"/>
-          <p:cNvSpPr txBox="1"/>
-          <p:nvPr/>
-        </p:nvSpPr>
-        <p:spPr>
-          <a:xfrm>
-            <a:off x="438912" y="5362951"/>
+          <p:cNvPr id="24" name="TextBox 23"/>
+          <p:cNvSpPr txBox="1"/>
+          <p:nvPr/>
+        </p:nvSpPr>
+        <p:spPr>
+          <a:xfrm>
+            <a:off x="438912" y="6308592"/>
             <a:ext cx="2414016" cy="302513"/>
           </a:xfrm>
           <a:prstGeom prst="rect">
@@ -11792,13 +11894,13 @@
       </p:sp>
       <p:sp>
         <p:nvSpPr>
-          <p:cNvPr id="22" name="Rectangle 21"/>
+          <p:cNvPr id="25" name="Rectangle 24"/>
           <p:cNvSpPr/>
           <p:nvPr/>
         </p:nvSpPr>
         <p:spPr>
           <a:xfrm>
-            <a:off x="3108960" y="3438906"/>
+            <a:off x="3108960" y="4384547"/>
             <a:ext cx="2743200" cy="2427732"/>
           </a:xfrm>
           <a:prstGeom prst="rect">
@@ -11835,13 +11937,13 @@
       </p:sp>
       <p:sp>
         <p:nvSpPr>
-          <p:cNvPr id="23" name="TextBox 22"/>
-          <p:cNvSpPr txBox="1"/>
-          <p:nvPr/>
-        </p:nvSpPr>
-        <p:spPr>
-          <a:xfrm>
-            <a:off x="3273552" y="3566922"/>
+          <p:cNvPr id="26" name="TextBox 25"/>
+          <p:cNvSpPr txBox="1"/>
+          <p:nvPr/>
+        </p:nvSpPr>
+        <p:spPr>
+          <a:xfrm>
+            <a:off x="3273552" y="4512563"/>
             <a:ext cx="2414016" cy="283464"/>
           </a:xfrm>
           <a:prstGeom prst="rect">
@@ -11862,20 +11964,20 @@
                   <a:srgbClr val="A8DADC"/>
                 </a:solidFill>
               </a:rPr>
-              <a:t>Igniter</a:t>
-            </a:r>
-          </a:p>
-        </p:txBody>
-      </p:sp>
-      <p:sp>
-        <p:nvSpPr>
-          <p:cNvPr id="24" name="TextBox 23"/>
-          <p:cNvSpPr txBox="1"/>
-          <p:nvPr/>
-        </p:nvSpPr>
-        <p:spPr>
-          <a:xfrm>
-            <a:off x="3273552" y="3850386"/>
+              <a:t>Water Pump</a:t>
+            </a:r>
+          </a:p>
+        </p:txBody>
+      </p:sp>
+      <p:sp>
+        <p:nvSpPr>
+          <p:cNvPr id="27" name="TextBox 26"/>
+          <p:cNvSpPr txBox="1"/>
+          <p:nvPr/>
+        </p:nvSpPr>
+        <p:spPr>
+          <a:xfrm>
+            <a:off x="3273552" y="4796027"/>
             <a:ext cx="2414016" cy="302513"/>
           </a:xfrm>
           <a:prstGeom prst="rect">
@@ -11896,20 +11998,20 @@
                   <a:srgbClr val="FFFFFF"/>
                 </a:solidFill>
               </a:rPr>
-              <a:t>• IN  →  GPIO26</a:t>
-            </a:r>
-          </a:p>
-        </p:txBody>
-      </p:sp>
-      <p:sp>
-        <p:nvSpPr>
-          <p:cNvPr id="25" name="TextBox 24"/>
-          <p:cNvSpPr txBox="1"/>
-          <p:nvPr/>
-        </p:nvSpPr>
-        <p:spPr>
-          <a:xfrm>
-            <a:off x="3273552" y="4152899"/>
+              <a:t>• IN  →  GPIO27</a:t>
+            </a:r>
+          </a:p>
+        </p:txBody>
+      </p:sp>
+      <p:sp>
+        <p:nvSpPr>
+          <p:cNvPr id="28" name="TextBox 27"/>
+          <p:cNvSpPr txBox="1"/>
+          <p:nvPr/>
+        </p:nvSpPr>
+        <p:spPr>
+          <a:xfrm>
+            <a:off x="3273552" y="5098540"/>
             <a:ext cx="2414016" cy="302513"/>
           </a:xfrm>
           <a:prstGeom prst="rect">
@@ -11937,13 +12039,13 @@
       </p:sp>
       <p:sp>
         <p:nvSpPr>
-          <p:cNvPr id="26" name="TextBox 25"/>
-          <p:cNvSpPr txBox="1"/>
-          <p:nvPr/>
-        </p:nvSpPr>
-        <p:spPr>
-          <a:xfrm>
-            <a:off x="3273552" y="4455412"/>
+          <p:cNvPr id="29" name="TextBox 28"/>
+          <p:cNvSpPr txBox="1"/>
+          <p:nvPr/>
+        </p:nvSpPr>
+        <p:spPr>
+          <a:xfrm>
+            <a:off x="3273552" y="5401053"/>
             <a:ext cx="2414016" cy="302513"/>
           </a:xfrm>
           <a:prstGeom prst="rect">
@@ -11971,13 +12073,13 @@
       </p:sp>
       <p:sp>
         <p:nvSpPr>
-          <p:cNvPr id="27" name="TextBox 26"/>
-          <p:cNvSpPr txBox="1"/>
-          <p:nvPr/>
-        </p:nvSpPr>
-        <p:spPr>
-          <a:xfrm>
-            <a:off x="3273552" y="4757925"/>
+          <p:cNvPr id="30" name="TextBox 29"/>
+          <p:cNvSpPr txBox="1"/>
+          <p:nvPr/>
+        </p:nvSpPr>
+        <p:spPr>
+          <a:xfrm>
+            <a:off x="3273552" y="5703566"/>
             <a:ext cx="2414016" cy="302513"/>
           </a:xfrm>
           <a:prstGeom prst="rect">
@@ -12005,13 +12107,13 @@
       </p:sp>
       <p:sp>
         <p:nvSpPr>
-          <p:cNvPr id="28" name="TextBox 27"/>
-          <p:cNvSpPr txBox="1"/>
-          <p:nvPr/>
-        </p:nvSpPr>
-        <p:spPr>
-          <a:xfrm>
-            <a:off x="3273552" y="5060438"/>
+          <p:cNvPr id="31" name="TextBox 30"/>
+          <p:cNvSpPr txBox="1"/>
+          <p:nvPr/>
+        </p:nvSpPr>
+        <p:spPr>
+          <a:xfrm>
+            <a:off x="3273552" y="6006079"/>
             <a:ext cx="2414016" cy="302513"/>
           </a:xfrm>
           <a:prstGeom prst="rect">
@@ -12039,13 +12141,13 @@
       </p:sp>
       <p:sp>
         <p:nvSpPr>
-          <p:cNvPr id="29" name="TextBox 28"/>
-          <p:cNvSpPr txBox="1"/>
-          <p:nvPr/>
-        </p:nvSpPr>
-        <p:spPr>
-          <a:xfrm>
-            <a:off x="3273552" y="5362951"/>
+          <p:cNvPr id="32" name="TextBox 31"/>
+          <p:cNvSpPr txBox="1"/>
+          <p:nvPr/>
+        </p:nvSpPr>
+        <p:spPr>
+          <a:xfrm>
+            <a:off x="3273552" y="6308592"/>
             <a:ext cx="2414016" cy="302513"/>
           </a:xfrm>
           <a:prstGeom prst="rect">
@@ -12066,21 +12168,21 @@
                   <a:srgbClr val="FFFFFF"/>
                 </a:solidFill>
               </a:rPr>
-              <a:t>• Electric heating element</a:t>
-            </a:r>
-          </a:p>
-        </p:txBody>
-      </p:sp>
-      <p:sp>
-        <p:nvSpPr>
-          <p:cNvPr id="30" name="Rectangle 29"/>
+              <a:t>• Circulation pump</a:t>
+            </a:r>
+          </a:p>
+        </p:txBody>
+      </p:sp>
+      <p:sp>
+        <p:nvSpPr>
+          <p:cNvPr id="33" name="Rectangle 32"/>
           <p:cNvSpPr/>
           <p:nvPr/>
         </p:nvSpPr>
         <p:spPr>
           <a:xfrm>
-            <a:off x="5943600" y="3438906"/>
-            <a:ext cx="2743200" cy="2427732"/>
+            <a:off x="8732520" y="4384547"/>
+            <a:ext cx="3108960" cy="3297174"/>
           </a:xfrm>
           <a:prstGeom prst="rect">
             <a:avLst/>
@@ -12116,14 +12218,14 @@
       </p:sp>
       <p:sp>
         <p:nvSpPr>
-          <p:cNvPr id="31" name="TextBox 30"/>
-          <p:cNvSpPr txBox="1"/>
-          <p:nvPr/>
-        </p:nvSpPr>
-        <p:spPr>
-          <a:xfrm>
-            <a:off x="6108192" y="3566922"/>
-            <a:ext cx="2414016" cy="283464"/>
+          <p:cNvPr id="34" name="TextBox 33"/>
+          <p:cNvSpPr txBox="1"/>
+          <p:nvPr/>
+        </p:nvSpPr>
+        <p:spPr>
+          <a:xfrm>
+            <a:off x="8897112" y="4512563"/>
+            <a:ext cx="2779776" cy="283464"/>
           </a:xfrm>
           <a:prstGeom prst="rect">
             <a:avLst/>
@@ -12143,21 +12245,21 @@
                   <a:srgbClr val="A8DADC"/>
                 </a:solidFill>
               </a:rPr>
-              <a:t>Water Pump</a:t>
-            </a:r>
-          </a:p>
-        </p:txBody>
-      </p:sp>
-      <p:sp>
-        <p:nvSpPr>
-          <p:cNvPr id="32" name="TextBox 31"/>
-          <p:cNvSpPr txBox="1"/>
-          <p:nvPr/>
-        </p:nvSpPr>
-        <p:spPr>
-          <a:xfrm>
-            <a:off x="6108192" y="3850386"/>
-            <a:ext cx="2414016" cy="302513"/>
+              <a:t>Active LOW wiring note</a:t>
+            </a:r>
+          </a:p>
+        </p:txBody>
+      </p:sp>
+      <p:sp>
+        <p:nvSpPr>
+          <p:cNvPr id="35" name="TextBox 34"/>
+          <p:cNvSpPr txBox="1"/>
+          <p:nvPr/>
+        </p:nvSpPr>
+        <p:spPr>
+          <a:xfrm>
+            <a:off x="8897112" y="4796027"/>
+            <a:ext cx="2779776" cy="302513"/>
           </a:xfrm>
           <a:prstGeom prst="rect">
             <a:avLst/>
@@ -12177,21 +12279,21 @@
                   <a:srgbClr val="FFFFFF"/>
                 </a:solidFill>
               </a:rPr>
-              <a:t>• IN  →  GPIO27</a:t>
-            </a:r>
-          </a:p>
-        </p:txBody>
-      </p:sp>
-      <p:sp>
-        <p:nvSpPr>
-          <p:cNvPr id="33" name="TextBox 32"/>
-          <p:cNvSpPr txBox="1"/>
-          <p:nvPr/>
-        </p:nvSpPr>
-        <p:spPr>
-          <a:xfrm>
-            <a:off x="6108192" y="4152899"/>
-            <a:ext cx="2414016" cy="302513"/>
+              <a:t>• ESP32 GPIO init HIGH at boot →</a:t>
+            </a:r>
+          </a:p>
+        </p:txBody>
+      </p:sp>
+      <p:sp>
+        <p:nvSpPr>
+          <p:cNvPr id="36" name="TextBox 35"/>
+          <p:cNvSpPr txBox="1"/>
+          <p:nvPr/>
+        </p:nvSpPr>
+        <p:spPr>
+          <a:xfrm>
+            <a:off x="8897112" y="5098540"/>
+            <a:ext cx="2779776" cy="302513"/>
           </a:xfrm>
           <a:prstGeom prst="rect">
             <a:avLst/>
@@ -12211,21 +12313,21 @@
                   <a:srgbClr val="FFFFFF"/>
                 </a:solidFill>
               </a:rPr>
-              <a:t>• VCC →  5V</a:t>
-            </a:r>
-          </a:p>
-        </p:txBody>
-      </p:sp>
-      <p:sp>
-        <p:nvSpPr>
-          <p:cNvPr id="34" name="TextBox 33"/>
-          <p:cNvSpPr txBox="1"/>
-          <p:nvPr/>
-        </p:nvSpPr>
-        <p:spPr>
-          <a:xfrm>
-            <a:off x="6108192" y="4455412"/>
-            <a:ext cx="2414016" cy="302513"/>
+              <a:t>• relay stays OFF during reset/startup</a:t>
+            </a:r>
+          </a:p>
+        </p:txBody>
+      </p:sp>
+      <p:sp>
+        <p:nvSpPr>
+          <p:cNvPr id="37" name="TextBox 36"/>
+          <p:cNvSpPr txBox="1"/>
+          <p:nvPr/>
+        </p:nvSpPr>
+        <p:spPr>
+          <a:xfrm>
+            <a:off x="8897112" y="5401053"/>
+            <a:ext cx="2779776" cy="302513"/>
           </a:xfrm>
           <a:prstGeom prst="rect">
             <a:avLst/>
@@ -12245,21 +12347,55 @@
                   <a:srgbClr val="FFFFFF"/>
                 </a:solidFill>
               </a:rPr>
-              <a:t>• GND →  GND</a:t>
-            </a:r>
-          </a:p>
-        </p:txBody>
-      </p:sp>
-      <p:sp>
-        <p:nvSpPr>
-          <p:cNvPr id="35" name="TextBox 34"/>
-          <p:cNvSpPr txBox="1"/>
-          <p:nvPr/>
-        </p:nvSpPr>
-        <p:spPr>
-          <a:xfrm>
-            <a:off x="6108192" y="4757925"/>
-            <a:ext cx="2414016" cy="302513"/>
+              <a:t>• LOW = relay ON,  HIGH = relay OFF</a:t>
+            </a:r>
+          </a:p>
+        </p:txBody>
+      </p:sp>
+      <p:sp>
+        <p:nvSpPr>
+          <p:cNvPr id="38" name="TextBox 37"/>
+          <p:cNvSpPr txBox="1"/>
+          <p:nvPr/>
+        </p:nvSpPr>
+        <p:spPr>
+          <a:xfrm>
+            <a:off x="8897112" y="5703566"/>
+            <a:ext cx="2779776" cy="283464"/>
+          </a:xfrm>
+          <a:prstGeom prst="rect">
+            <a:avLst/>
+          </a:prstGeom>
+          <a:noFill/>
+        </p:spPr>
+        <p:txBody>
+          <a:bodyPr wrap="square">
+            <a:spAutoFit/>
+          </a:bodyPr>
+          <a:lstStyle/>
+          <a:p>
+            <a:pPr algn="l"/>
+            <a:r>
+              <a:rPr sz="1200" b="1">
+                <a:solidFill>
+                  <a:srgbClr val="A8DADC"/>
+                </a:solidFill>
+              </a:rPr>
+              <a:t>Safety</a:t>
+            </a:r>
+          </a:p>
+        </p:txBody>
+      </p:sp>
+      <p:sp>
+        <p:nvSpPr>
+          <p:cNvPr id="39" name="TextBox 38"/>
+          <p:cNvSpPr txBox="1"/>
+          <p:nvPr/>
+        </p:nvSpPr>
+        <p:spPr>
+          <a:xfrm>
+            <a:off x="8897112" y="5987030"/>
+            <a:ext cx="2779776" cy="302513"/>
           </a:xfrm>
           <a:prstGeom prst="rect">
             <a:avLst/>
@@ -12279,21 +12415,21 @@
                   <a:srgbClr val="FFFFFF"/>
                 </a:solidFill>
               </a:rPr>
-              <a:t>• COM →  AC Live</a:t>
-            </a:r>
-          </a:p>
-        </p:txBody>
-      </p:sp>
-      <p:sp>
-        <p:nvSpPr>
-          <p:cNvPr id="36" name="TextBox 35"/>
-          <p:cNvSpPr txBox="1"/>
-          <p:nvPr/>
-        </p:nvSpPr>
-        <p:spPr>
-          <a:xfrm>
-            <a:off x="6108192" y="5060438"/>
-            <a:ext cx="2414016" cy="302513"/>
+              <a:t>• All relays default OFF on power-up</a:t>
+            </a:r>
+          </a:p>
+        </p:txBody>
+      </p:sp>
+      <p:sp>
+        <p:nvSpPr>
+          <p:cNvPr id="40" name="TextBox 39"/>
+          <p:cNvSpPr txBox="1"/>
+          <p:nvPr/>
+        </p:nvSpPr>
+        <p:spPr>
+          <a:xfrm>
+            <a:off x="8897112" y="6289543"/>
+            <a:ext cx="2779776" cy="302513"/>
           </a:xfrm>
           <a:prstGeom prst="rect">
             <a:avLst/>
@@ -12313,21 +12449,55 @@
                   <a:srgbClr val="FFFFFF"/>
                 </a:solidFill>
               </a:rPr>
-              <a:t>• NO  →  Load</a:t>
-            </a:r>
-          </a:p>
-        </p:txBody>
-      </p:sp>
-      <p:sp>
-        <p:nvSpPr>
-          <p:cNvPr id="37" name="TextBox 36"/>
-          <p:cNvSpPr txBox="1"/>
-          <p:nvPr/>
-        </p:nvSpPr>
-        <p:spPr>
-          <a:xfrm>
-            <a:off x="6108192" y="5362951"/>
-            <a:ext cx="2414016" cy="302513"/>
+              <a:t>• Emergency stop: all GPIOs → HIGH</a:t>
+            </a:r>
+          </a:p>
+        </p:txBody>
+      </p:sp>
+      <p:sp>
+        <p:nvSpPr>
+          <p:cNvPr id="41" name="TextBox 40"/>
+          <p:cNvSpPr txBox="1"/>
+          <p:nvPr/>
+        </p:nvSpPr>
+        <p:spPr>
+          <a:xfrm>
+            <a:off x="8897112" y="6592056"/>
+            <a:ext cx="2779776" cy="283464"/>
+          </a:xfrm>
+          <a:prstGeom prst="rect">
+            <a:avLst/>
+          </a:prstGeom>
+          <a:noFill/>
+        </p:spPr>
+        <p:txBody>
+          <a:bodyPr wrap="square">
+            <a:spAutoFit/>
+          </a:bodyPr>
+          <a:lstStyle/>
+          <a:p>
+            <a:pPr algn="l"/>
+            <a:r>
+              <a:rPr sz="1200" b="1">
+                <a:solidFill>
+                  <a:srgbClr val="A8DADC"/>
+                </a:solidFill>
+              </a:rPr>
+              <a:t>Decoupling</a:t>
+            </a:r>
+          </a:p>
+        </p:txBody>
+      </p:sp>
+      <p:sp>
+        <p:nvSpPr>
+          <p:cNvPr id="42" name="TextBox 41"/>
+          <p:cNvSpPr txBox="1"/>
+          <p:nvPr/>
+        </p:nvSpPr>
+        <p:spPr>
+          <a:xfrm>
+            <a:off x="8897112" y="6875520"/>
+            <a:ext cx="2779776" cy="302513"/>
           </a:xfrm>
           <a:prstGeom prst="rect">
             <a:avLst/>
@@ -12347,97 +12517,20 @@
                   <a:srgbClr val="FFFFFF"/>
                 </a:solidFill>
               </a:rPr>
-              <a:t>• Circulation pump</a:t>
-            </a:r>
-          </a:p>
-        </p:txBody>
-      </p:sp>
-      <p:sp>
-        <p:nvSpPr>
-          <p:cNvPr id="38" name="Rectangle 37"/>
-          <p:cNvSpPr/>
-          <p:nvPr/>
-        </p:nvSpPr>
-        <p:spPr>
-          <a:xfrm>
-            <a:off x="8732520" y="3438906"/>
-            <a:ext cx="3108960" cy="2408682"/>
-          </a:xfrm>
-          <a:prstGeom prst="rect">
-            <a:avLst/>
-          </a:prstGeom>
-          <a:solidFill>
-            <a:srgbClr val="16213E"/>
-          </a:solidFill>
-          <a:ln>
-            <a:noFill/>
-          </a:ln>
-        </p:spPr>
-        <p:style>
-          <a:lnRef idx="1">
-            <a:schemeClr val="accent1"/>
-          </a:lnRef>
-          <a:fillRef idx="3">
-            <a:schemeClr val="accent1"/>
-          </a:fillRef>
-          <a:effectRef idx="2">
-            <a:schemeClr val="accent1"/>
-          </a:effectRef>
-          <a:fontRef idx="minor">
-            <a:schemeClr val="lt1"/>
-          </a:fontRef>
-        </p:style>
-        <p:txBody>
-          <a:bodyPr rtlCol="0" anchor="ctr"/>
-          <a:lstStyle/>
-          <a:p>
-            <a:pPr algn="ctr"/>
-          </a:p>
-        </p:txBody>
-      </p:sp>
-      <p:sp>
-        <p:nvSpPr>
-          <p:cNvPr id="39" name="TextBox 38"/>
-          <p:cNvSpPr txBox="1"/>
-          <p:nvPr/>
-        </p:nvSpPr>
-        <p:spPr>
-          <a:xfrm>
-            <a:off x="8897112" y="3566922"/>
-            <a:ext cx="2779776" cy="283464"/>
-          </a:xfrm>
-          <a:prstGeom prst="rect">
-            <a:avLst/>
-          </a:prstGeom>
-          <a:noFill/>
-        </p:spPr>
-        <p:txBody>
-          <a:bodyPr wrap="square">
-            <a:spAutoFit/>
-          </a:bodyPr>
-          <a:lstStyle/>
-          <a:p>
-            <a:pPr algn="l"/>
-            <a:r>
-              <a:rPr sz="1200" b="1">
-                <a:solidFill>
-                  <a:srgbClr val="A8DADC"/>
-                </a:solidFill>
-              </a:rPr>
-              <a:t>Active LOW wiring note</a:t>
-            </a:r>
-          </a:p>
-        </p:txBody>
-      </p:sp>
-      <p:sp>
-        <p:nvSpPr>
-          <p:cNvPr id="40" name="TextBox 39"/>
-          <p:cNvSpPr txBox="1"/>
-          <p:nvPr/>
-        </p:nvSpPr>
-        <p:spPr>
-          <a:xfrm>
-            <a:off x="8897112" y="3850386"/>
+              <a:t>• 100 nF ceramic cap across VCC/GND</a:t>
+            </a:r>
+          </a:p>
+        </p:txBody>
+      </p:sp>
+      <p:sp>
+        <p:nvSpPr>
+          <p:cNvPr id="43" name="TextBox 42"/>
+          <p:cNvSpPr txBox="1"/>
+          <p:nvPr/>
+        </p:nvSpPr>
+        <p:spPr>
+          <a:xfrm>
+            <a:off x="8897112" y="7178033"/>
             <a:ext cx="2779776" cy="302513"/>
           </a:xfrm>
           <a:prstGeom prst="rect">
@@ -12458,177 +12551,7 @@
                   <a:srgbClr val="FFFFFF"/>
                 </a:solidFill>
               </a:rPr>
-              <a:t>• ESP32 GPIO init HIGH at boot →</a:t>
-            </a:r>
-          </a:p>
-        </p:txBody>
-      </p:sp>
-      <p:sp>
-        <p:nvSpPr>
-          <p:cNvPr id="41" name="TextBox 40"/>
-          <p:cNvSpPr txBox="1"/>
-          <p:nvPr/>
-        </p:nvSpPr>
-        <p:spPr>
-          <a:xfrm>
-            <a:off x="8897112" y="4152899"/>
-            <a:ext cx="2779776" cy="302513"/>
-          </a:xfrm>
-          <a:prstGeom prst="rect">
-            <a:avLst/>
-          </a:prstGeom>
-          <a:noFill/>
-        </p:spPr>
-        <p:txBody>
-          <a:bodyPr wrap="square">
-            <a:spAutoFit/>
-          </a:bodyPr>
-          <a:lstStyle/>
-          <a:p>
-            <a:pPr algn="l"/>
-            <a:r>
-              <a:rPr sz="1300" b="0">
-                <a:solidFill>
-                  <a:srgbClr val="FFFFFF"/>
-                </a:solidFill>
-              </a:rPr>
-              <a:t>• relay stays OFF during reset/startup</a:t>
-            </a:r>
-          </a:p>
-        </p:txBody>
-      </p:sp>
-      <p:sp>
-        <p:nvSpPr>
-          <p:cNvPr id="42" name="TextBox 41"/>
-          <p:cNvSpPr txBox="1"/>
-          <p:nvPr/>
-        </p:nvSpPr>
-        <p:spPr>
-          <a:xfrm>
-            <a:off x="8897112" y="4455412"/>
-            <a:ext cx="2779776" cy="302513"/>
-          </a:xfrm>
-          <a:prstGeom prst="rect">
-            <a:avLst/>
-          </a:prstGeom>
-          <a:noFill/>
-        </p:spPr>
-        <p:txBody>
-          <a:bodyPr wrap="square">
-            <a:spAutoFit/>
-          </a:bodyPr>
-          <a:lstStyle/>
-          <a:p>
-            <a:pPr algn="l"/>
-            <a:r>
-              <a:rPr sz="1300" b="0">
-                <a:solidFill>
-                  <a:srgbClr val="FFFFFF"/>
-                </a:solidFill>
-              </a:rPr>
-              <a:t>• LOW = relay ON,  HIGH = relay OFF</a:t>
-            </a:r>
-          </a:p>
-        </p:txBody>
-      </p:sp>
-      <p:sp>
-        <p:nvSpPr>
-          <p:cNvPr id="43" name="TextBox 42"/>
-          <p:cNvSpPr txBox="1"/>
-          <p:nvPr/>
-        </p:nvSpPr>
-        <p:spPr>
-          <a:xfrm>
-            <a:off x="8897112" y="4757925"/>
-            <a:ext cx="2779776" cy="283464"/>
-          </a:xfrm>
-          <a:prstGeom prst="rect">
-            <a:avLst/>
-          </a:prstGeom>
-          <a:noFill/>
-        </p:spPr>
-        <p:txBody>
-          <a:bodyPr wrap="square">
-            <a:spAutoFit/>
-          </a:bodyPr>
-          <a:lstStyle/>
-          <a:p>
-            <a:pPr algn="l"/>
-            <a:r>
-              <a:rPr sz="1200" b="1">
-                <a:solidFill>
-                  <a:srgbClr val="A8DADC"/>
-                </a:solidFill>
-              </a:rPr>
-              <a:t>Safety</a:t>
-            </a:r>
-          </a:p>
-        </p:txBody>
-      </p:sp>
-      <p:sp>
-        <p:nvSpPr>
-          <p:cNvPr id="44" name="TextBox 43"/>
-          <p:cNvSpPr txBox="1"/>
-          <p:nvPr/>
-        </p:nvSpPr>
-        <p:spPr>
-          <a:xfrm>
-            <a:off x="8897112" y="5041389"/>
-            <a:ext cx="2779776" cy="302513"/>
-          </a:xfrm>
-          <a:prstGeom prst="rect">
-            <a:avLst/>
-          </a:prstGeom>
-          <a:noFill/>
-        </p:spPr>
-        <p:txBody>
-          <a:bodyPr wrap="square">
-            <a:spAutoFit/>
-          </a:bodyPr>
-          <a:lstStyle/>
-          <a:p>
-            <a:pPr algn="l"/>
-            <a:r>
-              <a:rPr sz="1300" b="0">
-                <a:solidFill>
-                  <a:srgbClr val="FFFFFF"/>
-                </a:solidFill>
-              </a:rPr>
-              <a:t>• All relays default OFF on power-up</a:t>
-            </a:r>
-          </a:p>
-        </p:txBody>
-      </p:sp>
-      <p:sp>
-        <p:nvSpPr>
-          <p:cNvPr id="45" name="TextBox 44"/>
-          <p:cNvSpPr txBox="1"/>
-          <p:nvPr/>
-        </p:nvSpPr>
-        <p:spPr>
-          <a:xfrm>
-            <a:off x="8897112" y="5343902"/>
-            <a:ext cx="2779776" cy="302513"/>
-          </a:xfrm>
-          <a:prstGeom prst="rect">
-            <a:avLst/>
-          </a:prstGeom>
-          <a:noFill/>
-        </p:spPr>
-        <p:txBody>
-          <a:bodyPr wrap="square">
-            <a:spAutoFit/>
-          </a:bodyPr>
-          <a:lstStyle/>
-          <a:p>
-            <a:pPr algn="l"/>
-            <a:r>
-              <a:rPr sz="1300" b="0">
-                <a:solidFill>
-                  <a:srgbClr val="FFFFFF"/>
-                </a:solidFill>
-              </a:rPr>
-              <a:t>• Emergency stop: all GPIOs → HIGH</a:t>
+              <a:t>• at each relay module — prevents spikes</a:t>
             </a:r>
           </a:p>
         </p:txBody>
@@ -12723,7 +12646,7 @@
                   <a:srgbClr val="E94560"/>
                 </a:solidFill>
               </a:rPr>
-              <a:t>TRIAC Dimmer  —  Blower Motor Speed Control</a:t>
+              <a:t>2-Channel AC Dimmer  —  Blower &amp; Igniter</a:t>
             </a:r>
           </a:p>
         </p:txBody>
@@ -12845,7 +12768,7 @@
                   <a:srgbClr val="A8DADC"/>
                 </a:solidFill>
               </a:rPr>
-              <a:t>TRIAC / AC Dimmer</a:t>
+              <a:t>Hipzeepo 2-ch Dimmer</a:t>
             </a:r>
           </a:p>
         </p:txBody>
@@ -12859,7 +12782,7 @@
         <p:spPr>
           <a:xfrm>
             <a:off x="274320" y="749808"/>
-            <a:ext cx="4937760" cy="4828794"/>
+            <a:ext cx="4937760" cy="3902202"/>
           </a:xfrm>
           <a:prstGeom prst="rect">
             <a:avLst/>
@@ -12922,7 +12845,7 @@
                   <a:srgbClr val="A8DADC"/>
                 </a:solidFill>
               </a:rPr>
-              <a:t>Method: Phase-angle control</a:t>
+              <a:t>Module: Hipzeepo 2-Channel AC Dimmer</a:t>
             </a:r>
           </a:p>
         </p:txBody>
@@ -12956,7 +12879,7 @@
                   <a:srgbClr val="FFFFFF"/>
                 </a:solidFill>
               </a:rPr>
-              <a:t>• The AC waveform is chopped each half-cycle.</a:t>
+              <a:t>• 3.3V / 5V logic  ·  110V / 220V AC load</a:t>
             </a:r>
           </a:p>
         </p:txBody>
@@ -12990,7 +12913,7 @@
                   <a:srgbClr val="FFFFFF"/>
                 </a:solidFill>
               </a:rPr>
-              <a:t>• TRIAC fires later in the cycle → less power.</a:t>
+              <a:t>• Phase-angle control — variable AC power</a:t>
             </a:r>
           </a:p>
         </p:txBody>
@@ -13004,6 +12927,40 @@
         <p:spPr>
           <a:xfrm>
             <a:off x="438912" y="1766314"/>
+            <a:ext cx="4608576" cy="283464"/>
+          </a:xfrm>
+          <a:prstGeom prst="rect">
+            <a:avLst/>
+          </a:prstGeom>
+          <a:noFill/>
+        </p:spPr>
+        <p:txBody>
+          <a:bodyPr wrap="square">
+            <a:spAutoFit/>
+          </a:bodyPr>
+          <a:lstStyle/>
+          <a:p>
+            <a:pPr algn="l"/>
+            <a:r>
+              <a:rPr sz="1200" b="1">
+                <a:solidFill>
+                  <a:srgbClr val="A8DADC"/>
+                </a:solidFill>
+              </a:rPr>
+              <a:t>Built into the module (no discrete parts needed)</a:t>
+            </a:r>
+          </a:p>
+        </p:txBody>
+      </p:sp>
+      <p:sp>
+        <p:nvSpPr>
+          <p:cNvPr id="12" name="TextBox 11"/>
+          <p:cNvSpPr txBox="1"/>
+          <p:nvPr/>
+        </p:nvSpPr>
+        <p:spPr>
+          <a:xfrm>
+            <a:off x="438912" y="2049778"/>
             <a:ext cx="4608576" cy="302513"/>
           </a:xfrm>
           <a:prstGeom prst="rect">
@@ -13024,20 +12981,20 @@
                   <a:srgbClr val="FFFFFF"/>
                 </a:solidFill>
               </a:rPr>
-              <a:t>• Zero-cross detector tells ESP32 exactly when</a:t>
-            </a:r>
-          </a:p>
-        </p:txBody>
-      </p:sp>
-      <p:sp>
-        <p:nvSpPr>
-          <p:cNvPr id="12" name="TextBox 11"/>
-          <p:cNvSpPr txBox="1"/>
-          <p:nvPr/>
-        </p:nvSpPr>
-        <p:spPr>
-          <a:xfrm>
-            <a:off x="438912" y="2068827"/>
+              <a:t>• TRIAC × 2 (one per channel)</a:t>
+            </a:r>
+          </a:p>
+        </p:txBody>
+      </p:sp>
+      <p:sp>
+        <p:nvSpPr>
+          <p:cNvPr id="13" name="TextBox 12"/>
+          <p:cNvSpPr txBox="1"/>
+          <p:nvPr/>
+        </p:nvSpPr>
+        <p:spPr>
+          <a:xfrm>
+            <a:off x="438912" y="2352291"/>
             <a:ext cx="4608576" cy="302513"/>
           </a:xfrm>
           <a:prstGeom prst="rect">
@@ -13058,20 +13015,20 @@
                   <a:srgbClr val="FFFFFF"/>
                 </a:solidFill>
               </a:rPr>
-              <a:t>• the AC wave crosses 0V.</a:t>
-            </a:r>
-          </a:p>
-        </p:txBody>
-      </p:sp>
-      <p:sp>
-        <p:nvSpPr>
-          <p:cNvPr id="13" name="TextBox 12"/>
-          <p:cNvSpPr txBox="1"/>
-          <p:nvPr/>
-        </p:nvSpPr>
-        <p:spPr>
-          <a:xfrm>
-            <a:off x="438912" y="2371340"/>
+              <a:t>• Optocouplers for gate isolation</a:t>
+            </a:r>
+          </a:p>
+        </p:txBody>
+      </p:sp>
+      <p:sp>
+        <p:nvSpPr>
+          <p:cNvPr id="14" name="TextBox 13"/>
+          <p:cNvSpPr txBox="1"/>
+          <p:nvPr/>
+        </p:nvSpPr>
+        <p:spPr>
+          <a:xfrm>
+            <a:off x="438912" y="2654804"/>
             <a:ext cx="4608576" cy="302513"/>
           </a:xfrm>
           <a:prstGeom prst="rect">
@@ -13092,20 +13049,20 @@
                   <a:srgbClr val="FFFFFF"/>
                 </a:solidFill>
               </a:rPr>
-              <a:t>• ESP32 waits N µs, then pulses the TRIAC gate</a:t>
-            </a:r>
-          </a:p>
-        </p:txBody>
-      </p:sp>
-      <p:sp>
-        <p:nvSpPr>
-          <p:cNvPr id="14" name="TextBox 13"/>
-          <p:cNvSpPr txBox="1"/>
-          <p:nvPr/>
-        </p:nvSpPr>
-        <p:spPr>
-          <a:xfrm>
-            <a:off x="438912" y="2673853"/>
+              <a:t>• Snubber circuits per channel</a:t>
+            </a:r>
+          </a:p>
+        </p:txBody>
+      </p:sp>
+      <p:sp>
+        <p:nvSpPr>
+          <p:cNvPr id="15" name="TextBox 14"/>
+          <p:cNvSpPr txBox="1"/>
+          <p:nvPr/>
+        </p:nvSpPr>
+        <p:spPr>
+          <a:xfrm>
+            <a:off x="438912" y="2957317"/>
             <a:ext cx="4608576" cy="302513"/>
           </a:xfrm>
           <a:prstGeom prst="rect">
@@ -13126,20 +13083,54 @@
                   <a:srgbClr val="FFFFFF"/>
                 </a:solidFill>
               </a:rPr>
-              <a:t>• → conducts for the rest of the half-cycle.</a:t>
-            </a:r>
-          </a:p>
-        </p:txBody>
-      </p:sp>
-      <p:sp>
-        <p:nvSpPr>
-          <p:cNvPr id="15" name="TextBox 14"/>
-          <p:cNvSpPr txBox="1"/>
-          <p:nvPr/>
-        </p:nvSpPr>
-        <p:spPr>
-          <a:xfrm>
-            <a:off x="438912" y="2976366"/>
+              <a:t>• Zero-cross detector (shared ZC output)</a:t>
+            </a:r>
+          </a:p>
+        </p:txBody>
+      </p:sp>
+      <p:sp>
+        <p:nvSpPr>
+          <p:cNvPr id="16" name="TextBox 15"/>
+          <p:cNvSpPr txBox="1"/>
+          <p:nvPr/>
+        </p:nvSpPr>
+        <p:spPr>
+          <a:xfrm>
+            <a:off x="438912" y="3259830"/>
+            <a:ext cx="4608576" cy="283464"/>
+          </a:xfrm>
+          <a:prstGeom prst="rect">
+            <a:avLst/>
+          </a:prstGeom>
+          <a:noFill/>
+        </p:spPr>
+        <p:txBody>
+          <a:bodyPr wrap="square">
+            <a:spAutoFit/>
+          </a:bodyPr>
+          <a:lstStyle/>
+          <a:p>
+            <a:pPr algn="l"/>
+            <a:r>
+              <a:rPr sz="1200" b="1">
+                <a:solidFill>
+                  <a:srgbClr val="A8DADC"/>
+                </a:solidFill>
+              </a:rPr>
+              <a:t>Control method</a:t>
+            </a:r>
+          </a:p>
+        </p:txBody>
+      </p:sp>
+      <p:sp>
+        <p:nvSpPr>
+          <p:cNvPr id="17" name="TextBox 16"/>
+          <p:cNvSpPr txBox="1"/>
+          <p:nvPr/>
+        </p:nvSpPr>
+        <p:spPr>
+          <a:xfrm>
+            <a:off x="438912" y="3543294"/>
             <a:ext cx="4608576" cy="302513"/>
           </a:xfrm>
           <a:prstGeom prst="rect">
@@ -13160,20 +13151,20 @@
                   <a:srgbClr val="FFFFFF"/>
                 </a:solidFill>
               </a:rPr>
-              <a:t>• Larger delay = lower fan speed.</a:t>
-            </a:r>
-          </a:p>
-        </p:txBody>
-      </p:sp>
-      <p:sp>
-        <p:nvSpPr>
-          <p:cNvPr id="16" name="TextBox 15"/>
-          <p:cNvSpPr txBox="1"/>
-          <p:nvPr/>
-        </p:nvSpPr>
-        <p:spPr>
-          <a:xfrm>
-            <a:off x="438912" y="3278879"/>
+              <a:t>• PWM duty → phase angle → AC power %</a:t>
+            </a:r>
+          </a:p>
+        </p:txBody>
+      </p:sp>
+      <p:sp>
+        <p:nvSpPr>
+          <p:cNvPr id="18" name="TextBox 17"/>
+          <p:cNvSpPr txBox="1"/>
+          <p:nvPr/>
+        </p:nvSpPr>
+        <p:spPr>
+          <a:xfrm>
+            <a:off x="438912" y="3845807"/>
             <a:ext cx="4608576" cy="302513"/>
           </a:xfrm>
           <a:prstGeom prst="rect">
@@ -13194,54 +13185,20 @@
                   <a:srgbClr val="FFFFFF"/>
                 </a:solidFill>
               </a:rPr>
-              <a:t>• Delay = 0 = full power.</a:t>
-            </a:r>
-          </a:p>
-        </p:txBody>
-      </p:sp>
-      <p:sp>
-        <p:nvSpPr>
-          <p:cNvPr id="17" name="TextBox 16"/>
-          <p:cNvSpPr txBox="1"/>
-          <p:nvPr/>
-        </p:nvSpPr>
-        <p:spPr>
-          <a:xfrm>
-            <a:off x="438912" y="3581392"/>
-            <a:ext cx="4608576" cy="283464"/>
-          </a:xfrm>
-          <a:prstGeom prst="rect">
-            <a:avLst/>
-          </a:prstGeom>
-          <a:noFill/>
-        </p:spPr>
-        <p:txBody>
-          <a:bodyPr wrap="square">
-            <a:spAutoFit/>
-          </a:bodyPr>
-          <a:lstStyle/>
-          <a:p>
-            <a:pPr algn="l"/>
-            <a:r>
-              <a:rPr sz="1200" b="1">
-                <a:solidFill>
-                  <a:srgbClr val="A8DADC"/>
-                </a:solidFill>
-              </a:rPr>
-              <a:t>Typical components</a:t>
-            </a:r>
-          </a:p>
-        </p:txBody>
-      </p:sp>
-      <p:sp>
-        <p:nvSpPr>
-          <p:cNvPr id="18" name="TextBox 17"/>
-          <p:cNvSpPr txBox="1"/>
-          <p:nvPr/>
-        </p:nvSpPr>
-        <p:spPr>
-          <a:xfrm>
-            <a:off x="438912" y="3864856"/>
+              <a:t>• CH1 (blower): 0–100% fan speed</a:t>
+            </a:r>
+          </a:p>
+        </p:txBody>
+      </p:sp>
+      <p:sp>
+        <p:nvSpPr>
+          <p:cNvPr id="19" name="TextBox 18"/>
+          <p:cNvSpPr txBox="1"/>
+          <p:nvPr/>
+        </p:nvSpPr>
+        <p:spPr>
+          <a:xfrm>
+            <a:off x="438912" y="4148320"/>
             <a:ext cx="4608576" cy="302513"/>
           </a:xfrm>
           <a:prstGeom prst="rect">
@@ -13262,150 +13219,14 @@
                   <a:srgbClr val="FFFFFF"/>
                 </a:solidFill>
               </a:rPr>
-              <a:t>• BT136 or BTA16 TRIAC (TO-220)</a:t>
-            </a:r>
-          </a:p>
-        </p:txBody>
-      </p:sp>
-      <p:sp>
-        <p:nvSpPr>
-          <p:cNvPr id="19" name="TextBox 18"/>
-          <p:cNvSpPr txBox="1"/>
-          <p:nvPr/>
-        </p:nvSpPr>
-        <p:spPr>
-          <a:xfrm>
-            <a:off x="438912" y="4167369"/>
-            <a:ext cx="4608576" cy="302513"/>
-          </a:xfrm>
-          <a:prstGeom prst="rect">
-            <a:avLst/>
-          </a:prstGeom>
-          <a:noFill/>
-        </p:spPr>
-        <p:txBody>
-          <a:bodyPr wrap="square">
-            <a:spAutoFit/>
-          </a:bodyPr>
-          <a:lstStyle/>
-          <a:p>
-            <a:pPr algn="l"/>
-            <a:r>
-              <a:rPr sz="1300" b="0">
-                <a:solidFill>
-                  <a:srgbClr val="FFFFFF"/>
-                </a:solidFill>
-              </a:rPr>
-              <a:t>• MOC3021 optocoupler (gate isolation)</a:t>
-            </a:r>
-          </a:p>
-        </p:txBody>
-      </p:sp>
-      <p:sp>
-        <p:nvSpPr>
-          <p:cNvPr id="20" name="TextBox 19"/>
-          <p:cNvSpPr txBox="1"/>
-          <p:nvPr/>
-        </p:nvSpPr>
-        <p:spPr>
-          <a:xfrm>
-            <a:off x="438912" y="4469882"/>
-            <a:ext cx="4608576" cy="302513"/>
-          </a:xfrm>
-          <a:prstGeom prst="rect">
-            <a:avLst/>
-          </a:prstGeom>
-          <a:noFill/>
-        </p:spPr>
-        <p:txBody>
-          <a:bodyPr wrap="square">
-            <a:spAutoFit/>
-          </a:bodyPr>
-          <a:lstStyle/>
-          <a:p>
-            <a:pPr algn="l"/>
-            <a:r>
-              <a:rPr sz="1300" b="0">
-                <a:solidFill>
-                  <a:srgbClr val="FFFFFF"/>
-                </a:solidFill>
-              </a:rPr>
-              <a:t>• 4N35 optocoupler (zero-cross isolation)</a:t>
-            </a:r>
-          </a:p>
-        </p:txBody>
-      </p:sp>
-      <p:sp>
-        <p:nvSpPr>
-          <p:cNvPr id="21" name="TextBox 20"/>
-          <p:cNvSpPr txBox="1"/>
-          <p:nvPr/>
-        </p:nvSpPr>
-        <p:spPr>
-          <a:xfrm>
-            <a:off x="438912" y="4772395"/>
-            <a:ext cx="4608576" cy="302513"/>
-          </a:xfrm>
-          <a:prstGeom prst="rect">
-            <a:avLst/>
-          </a:prstGeom>
-          <a:noFill/>
-        </p:spPr>
-        <p:txBody>
-          <a:bodyPr wrap="square">
-            <a:spAutoFit/>
-          </a:bodyPr>
-          <a:lstStyle/>
-          <a:p>
-            <a:pPr algn="l"/>
-            <a:r>
-              <a:rPr sz="1300" b="0">
-                <a:solidFill>
-                  <a:srgbClr val="FFFFFF"/>
-                </a:solidFill>
-              </a:rPr>
-              <a:t>• Snubber: 100Ω + 100nF/400V across TRIAC</a:t>
-            </a:r>
-          </a:p>
-        </p:txBody>
-      </p:sp>
-      <p:sp>
-        <p:nvSpPr>
-          <p:cNvPr id="22" name="TextBox 21"/>
-          <p:cNvSpPr txBox="1"/>
-          <p:nvPr/>
-        </p:nvSpPr>
-        <p:spPr>
-          <a:xfrm>
-            <a:off x="438912" y="5074908"/>
-            <a:ext cx="4608576" cy="302513"/>
-          </a:xfrm>
-          <a:prstGeom prst="rect">
-            <a:avLst/>
-          </a:prstGeom>
-          <a:noFill/>
-        </p:spPr>
-        <p:txBody>
-          <a:bodyPr wrap="square">
-            <a:spAutoFit/>
-          </a:bodyPr>
-          <a:lstStyle/>
-          <a:p>
-            <a:pPr algn="l"/>
-            <a:r>
-              <a:rPr sz="1300" b="0">
-                <a:solidFill>
-                  <a:srgbClr val="FFFFFF"/>
-                </a:solidFill>
-              </a:rPr>
-              <a:t>• Gate resistor: 330Ω before MOC3021</a:t>
-            </a:r>
-          </a:p>
-        </p:txBody>
-      </p:sp>
-      <p:sp>
-        <p:nvSpPr>
-          <p:cNvPr id="23" name="Rectangle 22"/>
+              <a:t>• CH2 (igniter): 0% = off, 100% = full heat</a:t>
+            </a:r>
+          </a:p>
+        </p:txBody>
+      </p:sp>
+      <p:sp>
+        <p:nvSpPr>
+          <p:cNvPr id="20" name="Rectangle 19"/>
           <p:cNvSpPr/>
           <p:nvPr/>
         </p:nvSpPr>
@@ -13448,7 +13269,7 @@
       </p:sp>
       <p:sp>
         <p:nvSpPr>
-          <p:cNvPr id="24" name="TextBox 23"/>
+          <p:cNvPr id="21" name="TextBox 20"/>
           <p:cNvSpPr txBox="1"/>
           <p:nvPr/>
         </p:nvSpPr>
@@ -13475,14 +13296,14 @@
                   <a:srgbClr val="A8DADC"/>
                 </a:solidFill>
               </a:rPr>
-              <a:t>Zero-cross input</a:t>
-            </a:r>
-          </a:p>
-        </p:txBody>
-      </p:sp>
-      <p:sp>
-        <p:nvSpPr>
-          <p:cNvPr id="25" name="TextBox 24"/>
+              <a:t>DC logic side — wiring to ESP32</a:t>
+            </a:r>
+          </a:p>
+        </p:txBody>
+      </p:sp>
+      <p:sp>
+        <p:nvSpPr>
+          <p:cNvPr id="22" name="TextBox 21"/>
           <p:cNvSpPr txBox="1"/>
           <p:nvPr/>
         </p:nvSpPr>
@@ -13509,14 +13330,14 @@
                   <a:srgbClr val="FFFFFF"/>
                 </a:solidFill>
               </a:rPr>
-              <a:t>• GPIO35  ←  Zero-cross signal</a:t>
-            </a:r>
-          </a:p>
-        </p:txBody>
-      </p:sp>
-      <p:sp>
-        <p:nvSpPr>
-          <p:cNvPr id="26" name="TextBox 25"/>
+              <a:t>• VCC  →  3.3V (or 5V)</a:t>
+            </a:r>
+          </a:p>
+        </p:txBody>
+      </p:sp>
+      <p:sp>
+        <p:nvSpPr>
+          <p:cNvPr id="23" name="TextBox 22"/>
           <p:cNvSpPr txBox="1"/>
           <p:nvPr/>
         </p:nvSpPr>
@@ -13543,14 +13364,14 @@
                   <a:srgbClr val="FFFFFF"/>
                 </a:solidFill>
               </a:rPr>
-              <a:t>• (GPIO35 is input-only on ESP32)</a:t>
-            </a:r>
-          </a:p>
-        </p:txBody>
-      </p:sp>
-      <p:sp>
-        <p:nvSpPr>
-          <p:cNvPr id="27" name="TextBox 26"/>
+              <a:t>• GND  →  GND bus</a:t>
+            </a:r>
+          </a:p>
+        </p:txBody>
+      </p:sp>
+      <p:sp>
+        <p:nvSpPr>
+          <p:cNvPr id="24" name="TextBox 23"/>
           <p:cNvSpPr txBox="1"/>
           <p:nvPr/>
         </p:nvSpPr>
@@ -13577,14 +13398,14 @@
                   <a:srgbClr val="FFFFFF"/>
                 </a:solidFill>
               </a:rPr>
-              <a:t>• Signal: HIGH normally, drops LOW at</a:t>
-            </a:r>
-          </a:p>
-        </p:txBody>
-      </p:sp>
-      <p:sp>
-        <p:nvSpPr>
-          <p:cNvPr id="28" name="TextBox 27"/>
+              <a:t>• ZC   →  GPIO35  (zero-cross, shared output)</a:t>
+            </a:r>
+          </a:p>
+        </p:txBody>
+      </p:sp>
+      <p:sp>
+        <p:nvSpPr>
+          <p:cNvPr id="25" name="TextBox 24"/>
           <p:cNvSpPr txBox="1"/>
           <p:nvPr/>
         </p:nvSpPr>
@@ -13611,14 +13432,14 @@
                   <a:srgbClr val="FFFFFF"/>
                 </a:solidFill>
               </a:rPr>
-              <a:t>• each zero crossing of the AC wave</a:t>
-            </a:r>
-          </a:p>
-        </p:txBody>
-      </p:sp>
-      <p:sp>
-        <p:nvSpPr>
-          <p:cNvPr id="29" name="TextBox 28"/>
+              <a:t>• DIM1 →  GPIO33  (CH1 — blower motor)</a:t>
+            </a:r>
+          </a:p>
+        </p:txBody>
+      </p:sp>
+      <p:sp>
+        <p:nvSpPr>
+          <p:cNvPr id="26" name="TextBox 25"/>
           <p:cNvSpPr txBox="1"/>
           <p:nvPr/>
         </p:nvSpPr>
@@ -13645,14 +13466,14 @@
                   <a:srgbClr val="FFFFFF"/>
                 </a:solidFill>
               </a:rPr>
-              <a:t>• Trigger ISR on falling edge</a:t>
-            </a:r>
-          </a:p>
-        </p:txBody>
-      </p:sp>
-      <p:sp>
-        <p:nvSpPr>
-          <p:cNvPr id="30" name="TextBox 29"/>
+              <a:t>• DIM2 →  GPIO26  (CH2 — igniter heater)</a:t>
+            </a:r>
+          </a:p>
+        </p:txBody>
+      </p:sp>
+      <p:sp>
+        <p:nvSpPr>
+          <p:cNvPr id="27" name="TextBox 26"/>
           <p:cNvSpPr txBox="1"/>
           <p:nvPr/>
         </p:nvSpPr>
@@ -13679,14 +13500,14 @@
                   <a:srgbClr val="A8DADC"/>
                 </a:solidFill>
               </a:rPr>
-              <a:t>TRIAC gate output</a:t>
-            </a:r>
-          </a:p>
-        </p:txBody>
-      </p:sp>
-      <p:sp>
-        <p:nvSpPr>
-          <p:cNvPr id="31" name="TextBox 30"/>
+              <a:t>AC load side</a:t>
+            </a:r>
+          </a:p>
+        </p:txBody>
+      </p:sp>
+      <p:sp>
+        <p:nvSpPr>
+          <p:cNvPr id="28" name="TextBox 27"/>
           <p:cNvSpPr txBox="1"/>
           <p:nvPr/>
         </p:nvSpPr>
@@ -13713,14 +13534,14 @@
                   <a:srgbClr val="FFFFFF"/>
                 </a:solidFill>
               </a:rPr>
-              <a:t>• GPIO33  →  330Ω  →  MOC3021 LED(+)</a:t>
-            </a:r>
-          </a:p>
-        </p:txBody>
-      </p:sp>
-      <p:sp>
-        <p:nvSpPr>
-          <p:cNvPr id="32" name="TextBox 31"/>
+              <a:t>• CH1 OUT  →  Blower motor (220V AC)</a:t>
+            </a:r>
+          </a:p>
+        </p:txBody>
+      </p:sp>
+      <p:sp>
+        <p:nvSpPr>
+          <p:cNvPr id="29" name="TextBox 28"/>
           <p:cNvSpPr txBox="1"/>
           <p:nvPr/>
         </p:nvSpPr>
@@ -13747,20 +13568,54 @@
                   <a:srgbClr val="FFFFFF"/>
                 </a:solidFill>
               </a:rPr>
-              <a:t>• MOC3021 output  →  TRIAC gate</a:t>
-            </a:r>
-          </a:p>
-        </p:txBody>
-      </p:sp>
-      <p:sp>
-        <p:nvSpPr>
-          <p:cNvPr id="33" name="TextBox 32"/>
+              <a:t>• CH2 OUT  →  Igniter heater (220V AC)</a:t>
+            </a:r>
+          </a:p>
+        </p:txBody>
+      </p:sp>
+      <p:sp>
+        <p:nvSpPr>
+          <p:cNvPr id="30" name="TextBox 29"/>
           <p:cNvSpPr txBox="1"/>
           <p:nvPr/>
         </p:nvSpPr>
         <p:spPr>
           <a:xfrm>
             <a:off x="5513832" y="3562343"/>
+            <a:ext cx="2871216" cy="302513"/>
+          </a:xfrm>
+          <a:prstGeom prst="rect">
+            <a:avLst/>
+          </a:prstGeom>
+          <a:noFill/>
+        </p:spPr>
+        <p:txBody>
+          <a:bodyPr wrap="square">
+            <a:spAutoFit/>
+          </a:bodyPr>
+          <a:lstStyle/>
+          <a:p>
+            <a:pPr algn="l"/>
+            <a:r>
+              <a:rPr sz="1300" b="0">
+                <a:solidFill>
+                  <a:srgbClr val="FFFFFF"/>
+                </a:solidFill>
+              </a:rPr>
+              <a:t>• AC IN    →  Mains L + N (via 5–10A fuse)</a:t>
+            </a:r>
+          </a:p>
+        </p:txBody>
+      </p:sp>
+      <p:sp>
+        <p:nvSpPr>
+          <p:cNvPr id="31" name="TextBox 30"/>
+          <p:cNvSpPr txBox="1"/>
+          <p:nvPr/>
+        </p:nvSpPr>
+        <p:spPr>
+          <a:xfrm>
+            <a:off x="5513832" y="3864856"/>
             <a:ext cx="2871216" cy="283464"/>
           </a:xfrm>
           <a:prstGeom prst="rect">
@@ -13781,48 +13636,14 @@
                   <a:srgbClr val="A8DADC"/>
                 </a:solidFill>
               </a:rPr>
-              <a:t>Voltage levels</a:t>
-            </a:r>
-          </a:p>
-        </p:txBody>
-      </p:sp>
-      <p:sp>
-        <p:nvSpPr>
-          <p:cNvPr id="34" name="TextBox 33"/>
-          <p:cNvSpPr txBox="1"/>
-          <p:nvPr/>
-        </p:nvSpPr>
-        <p:spPr>
-          <a:xfrm>
-            <a:off x="5513832" y="3845807"/>
-            <a:ext cx="2871216" cy="302513"/>
-          </a:xfrm>
-          <a:prstGeom prst="rect">
-            <a:avLst/>
-          </a:prstGeom>
-          <a:noFill/>
-        </p:spPr>
-        <p:txBody>
-          <a:bodyPr wrap="square">
-            <a:spAutoFit/>
-          </a:bodyPr>
-          <a:lstStyle/>
-          <a:p>
-            <a:pPr algn="l"/>
-            <a:r>
-              <a:rPr sz="1300" b="0">
-                <a:solidFill>
-                  <a:srgbClr val="FFFFFF"/>
-                </a:solidFill>
-              </a:rPr>
-              <a:t>• ESP32 side: 3.3V logic (optocoupled)</a:t>
-            </a:r>
-          </a:p>
-        </p:txBody>
-      </p:sp>
-      <p:sp>
-        <p:nvSpPr>
-          <p:cNvPr id="35" name="TextBox 34"/>
+              <a:t>Safety</a:t>
+            </a:r>
+          </a:p>
+        </p:txBody>
+      </p:sp>
+      <p:sp>
+        <p:nvSpPr>
+          <p:cNvPr id="32" name="TextBox 31"/>
           <p:cNvSpPr txBox="1"/>
           <p:nvPr/>
         </p:nvSpPr>
@@ -13849,14 +13670,14 @@
                   <a:srgbClr val="FFFFFF"/>
                 </a:solidFill>
               </a:rPr>
-              <a:t>• AC side: 230V AC — HIGH VOLTAGE</a:t>
-            </a:r>
-          </a:p>
-        </p:txBody>
-      </p:sp>
-      <p:sp>
-        <p:nvSpPr>
-          <p:cNvPr id="36" name="TextBox 35"/>
+              <a:t>• AC side: 230V — HIGH VOLTAGE</a:t>
+            </a:r>
+          </a:p>
+        </p:txBody>
+      </p:sp>
+      <p:sp>
+        <p:nvSpPr>
+          <p:cNvPr id="33" name="TextBox 32"/>
           <p:cNvSpPr txBox="1"/>
           <p:nvPr/>
         </p:nvSpPr>
@@ -13883,14 +13704,14 @@
                   <a:srgbClr val="FFFFFF"/>
                 </a:solidFill>
               </a:rPr>
-              <a:t>• Keep AC and DC wiring separated</a:t>
-            </a:r>
-          </a:p>
-        </p:txBody>
-      </p:sp>
-      <p:sp>
-        <p:nvSpPr>
-          <p:cNvPr id="37" name="TextBox 36"/>
+              <a:t>• Keep AC and DC wiring physically separated</a:t>
+            </a:r>
+          </a:p>
+        </p:txBody>
+      </p:sp>
+      <p:sp>
+        <p:nvSpPr>
+          <p:cNvPr id="34" name="TextBox 33"/>
           <p:cNvSpPr txBox="1"/>
           <p:nvPr/>
         </p:nvSpPr>
@@ -13917,7 +13738,7 @@
                   <a:srgbClr val="FFFFFF"/>
                 </a:solidFill>
               </a:rPr>
-              <a:t>• Fuse the AC circuit (5–10A slow blow)</a:t>
+              <a:t>• Fuse live wire before module AC IN</a:t>
             </a:r>
           </a:p>
         </p:txBody>
@@ -15874,7 +15695,7 @@
         <p:spPr>
           <a:xfrm>
             <a:off x="8046720" y="749808"/>
-            <a:ext cx="3840480" cy="2542032"/>
+            <a:ext cx="3840480" cy="2863596"/>
           </a:xfrm>
           <a:prstGeom prst="rect">
             <a:avLst/>
@@ -16005,7 +15826,7 @@
                   <a:srgbClr val="FFFFFF"/>
                 </a:solidFill>
               </a:rPr>
-              <a:t>• GPIO26 → Relay IN — Igniter</a:t>
+              <a:t>• GPIO27 → Relay IN — Water pump</a:t>
             </a:r>
           </a:p>
         </p:txBody>
@@ -16039,7 +15860,7 @@
                   <a:srgbClr val="FFFFFF"/>
                 </a:solidFill>
               </a:rPr>
-              <a:t>• GPIO27 → Relay IN — Pump</a:t>
+              <a:t>• Relay VCC → 5V   GND → GND</a:t>
             </a:r>
           </a:p>
         </p:txBody>
@@ -16053,6 +15874,40 @@
         <p:spPr>
           <a:xfrm>
             <a:off x="8211312" y="2145029"/>
+            <a:ext cx="3511296" cy="302513"/>
+          </a:xfrm>
+          <a:prstGeom prst="rect">
+            <a:avLst/>
+          </a:prstGeom>
+          <a:noFill/>
+        </p:spPr>
+        <p:txBody>
+          <a:bodyPr wrap="square">
+            <a:spAutoFit/>
+          </a:bodyPr>
+          <a:lstStyle/>
+          <a:p>
+            <a:pPr algn="l"/>
+            <a:r>
+              <a:rPr sz="1300" b="1">
+                <a:solidFill>
+                  <a:srgbClr val="A8DADC"/>
+                </a:solidFill>
+              </a:rPr>
+              <a:t>AC Dimmer  (2-ch Hipzeepo module)</a:t>
+            </a:r>
+          </a:p>
+        </p:txBody>
+      </p:sp>
+      <p:sp>
+        <p:nvSpPr>
+          <p:cNvPr id="30" name="TextBox 29"/>
+          <p:cNvSpPr txBox="1"/>
+          <p:nvPr/>
+        </p:nvSpPr>
+        <p:spPr>
+          <a:xfrm>
+            <a:off x="8211312" y="2447542"/>
             <a:ext cx="3511296" cy="321564"/>
           </a:xfrm>
           <a:prstGeom prst="rect">
@@ -16073,41 +15928,7 @@
                   <a:srgbClr val="FFFFFF"/>
                 </a:solidFill>
               </a:rPr>
-              <a:t>• Relay VCC → 5V   GND → GND</a:t>
-            </a:r>
-          </a:p>
-        </p:txBody>
-      </p:sp>
-      <p:sp>
-        <p:nvSpPr>
-          <p:cNvPr id="30" name="TextBox 29"/>
-          <p:cNvSpPr txBox="1"/>
-          <p:nvPr/>
-        </p:nvSpPr>
-        <p:spPr>
-          <a:xfrm>
-            <a:off x="8211312" y="2466593"/>
-            <a:ext cx="3511296" cy="302513"/>
-          </a:xfrm>
-          <a:prstGeom prst="rect">
-            <a:avLst/>
-          </a:prstGeom>
-          <a:noFill/>
-        </p:spPr>
-        <p:txBody>
-          <a:bodyPr wrap="square">
-            <a:spAutoFit/>
-          </a:bodyPr>
-          <a:lstStyle/>
-          <a:p>
-            <a:pPr algn="l"/>
-            <a:r>
-              <a:rPr sz="1300" b="1">
-                <a:solidFill>
-                  <a:srgbClr val="A8DADC"/>
-                </a:solidFill>
-              </a:rPr>
-              <a:t>TRIAC gate</a:t>
+              <a:t>• GPIO35 ← ZC   zero-cross in</a:t>
             </a:r>
           </a:p>
         </p:txBody>
@@ -16141,14 +15962,48 @@
                   <a:srgbClr val="FFFFFF"/>
                 </a:solidFill>
               </a:rPr>
-              <a:t>• GPIO33 → 330Ω → MOC3021 → TRIAC</a:t>
-            </a:r>
-          </a:p>
-        </p:txBody>
-      </p:sp>
-      <p:sp>
-        <p:nvSpPr>
-          <p:cNvPr id="32" name="Rectangle 31"/>
+              <a:t>• GPIO33 → DIM1  blower speed</a:t>
+            </a:r>
+          </a:p>
+        </p:txBody>
+      </p:sp>
+      <p:sp>
+        <p:nvSpPr>
+          <p:cNvPr id="32" name="TextBox 31"/>
+          <p:cNvSpPr txBox="1"/>
+          <p:nvPr/>
+        </p:nvSpPr>
+        <p:spPr>
+          <a:xfrm>
+            <a:off x="8211312" y="3090670"/>
+            <a:ext cx="3511296" cy="321564"/>
+          </a:xfrm>
+          <a:prstGeom prst="rect">
+            <a:avLst/>
+          </a:prstGeom>
+          <a:noFill/>
+        </p:spPr>
+        <p:txBody>
+          <a:bodyPr wrap="square">
+            <a:spAutoFit/>
+          </a:bodyPr>
+          <a:lstStyle/>
+          <a:p>
+            <a:pPr algn="l"/>
+            <a:r>
+              <a:rPr sz="1400" b="0">
+                <a:solidFill>
+                  <a:srgbClr val="FFFFFF"/>
+                </a:solidFill>
+              </a:rPr>
+              <a:t>• GPIO26 → DIM2  igniter on/off</a:t>
+            </a:r>
+          </a:p>
+        </p:txBody>
+      </p:sp>
+      <p:sp>
+        <p:nvSpPr>
+          <p:cNvPr id="33" name="Rectangle 32"/>
           <p:cNvSpPr/>
           <p:nvPr/>
         </p:nvSpPr>
@@ -16191,7 +16046,7 @@
       </p:sp>
       <p:sp>
         <p:nvSpPr>
-          <p:cNvPr id="33" name="TextBox 32"/>
+          <p:cNvPr id="34" name="TextBox 33"/>
           <p:cNvSpPr txBox="1"/>
           <p:nvPr/>
         </p:nvSpPr>
@@ -16225,7 +16080,7 @@
       </p:sp>
       <p:sp>
         <p:nvSpPr>
-          <p:cNvPr id="34" name="TextBox 33"/>
+          <p:cNvPr id="35" name="TextBox 34"/>
           <p:cNvSpPr txBox="1"/>
           <p:nvPr/>
         </p:nvSpPr>
@@ -16259,7 +16114,7 @@
       </p:sp>
       <p:sp>
         <p:nvSpPr>
-          <p:cNvPr id="35" name="TextBox 34"/>
+          <p:cNvPr id="36" name="TextBox 35"/>
           <p:cNvSpPr txBox="1"/>
           <p:nvPr/>
         </p:nvSpPr>
@@ -16293,7 +16148,7 @@
       </p:sp>
       <p:sp>
         <p:nvSpPr>
-          <p:cNvPr id="36" name="Rectangle 35"/>
+          <p:cNvPr id="37" name="Rectangle 36"/>
           <p:cNvSpPr/>
           <p:nvPr/>
         </p:nvSpPr>
@@ -16336,7 +16191,7 @@
       </p:sp>
       <p:sp>
         <p:nvSpPr>
-          <p:cNvPr id="37" name="TextBox 36"/>
+          <p:cNvPr id="38" name="TextBox 37"/>
           <p:cNvSpPr txBox="1"/>
           <p:nvPr/>
         </p:nvSpPr>
@@ -16370,7 +16225,7 @@
       </p:sp>
       <p:sp>
         <p:nvSpPr>
-          <p:cNvPr id="38" name="TextBox 37"/>
+          <p:cNvPr id="39" name="TextBox 38"/>
           <p:cNvSpPr txBox="1"/>
           <p:nvPr/>
         </p:nvSpPr>
@@ -16397,14 +16252,14 @@
                   <a:srgbClr val="FFFFFF"/>
                 </a:solidFill>
               </a:rPr>
-              <a:t>• 3.3V: ESP32 reg, OLED, DS18B20, MAX6675</a:t>
-            </a:r>
-          </a:p>
-        </p:txBody>
-      </p:sp>
-      <p:sp>
-        <p:nvSpPr>
-          <p:cNvPr id="39" name="TextBox 38"/>
+              <a:t>• 3.3V: ESP32 reg → OLED, sensors, dimmer</a:t>
+            </a:r>
+          </a:p>
+        </p:txBody>
+      </p:sp>
+      <p:sp>
+        <p:nvSpPr>
+          <p:cNvPr id="40" name="TextBox 39"/>
           <p:cNvSpPr txBox="1"/>
           <p:nvPr/>
         </p:nvSpPr>
@@ -16431,14 +16286,14 @@
                   <a:srgbClr val="FFFFFF"/>
                 </a:solidFill>
               </a:rPr>
-              <a:t>• 5V: Relay module VCC</a:t>
-            </a:r>
-          </a:p>
-        </p:txBody>
-      </p:sp>
-      <p:sp>
-        <p:nvSpPr>
-          <p:cNvPr id="40" name="TextBox 39"/>
+              <a:t>• 5V (HLK-PM01): relay VCC, ESP32 VIN</a:t>
+            </a:r>
+          </a:p>
+        </p:txBody>
+      </p:sp>
+      <p:sp>
+        <p:nvSpPr>
+          <p:cNvPr id="41" name="TextBox 40"/>
           <p:cNvSpPr txBox="1"/>
           <p:nvPr/>
         </p:nvSpPr>
@@ -16465,21 +16320,21 @@
                   <a:srgbClr val="FFFFFF"/>
                 </a:solidFill>
               </a:rPr>
-              <a:t>• AC 230V: TRIAC load side — isolated</a:t>
-            </a:r>
-          </a:p>
-        </p:txBody>
-      </p:sp>
-      <p:sp>
-        <p:nvSpPr>
-          <p:cNvPr id="41" name="Rectangle 40"/>
+              <a:t>• AC 230V: dimmer load side — isolated</a:t>
+            </a:r>
+          </a:p>
+        </p:txBody>
+      </p:sp>
+      <p:sp>
+        <p:nvSpPr>
+          <p:cNvPr id="42" name="Rectangle 41"/>
           <p:cNvSpPr/>
           <p:nvPr/>
         </p:nvSpPr>
         <p:spPr>
           <a:xfrm>
             <a:off x="8046720" y="4062983"/>
-            <a:ext cx="3840480" cy="1596390"/>
+            <a:ext cx="3840480" cy="1917954"/>
           </a:xfrm>
           <a:prstGeom prst="rect">
             <a:avLst/>
@@ -16515,7 +16370,7 @@
       </p:sp>
       <p:sp>
         <p:nvSpPr>
-          <p:cNvPr id="42" name="TextBox 41"/>
+          <p:cNvPr id="43" name="TextBox 42"/>
           <p:cNvSpPr txBox="1"/>
           <p:nvPr/>
         </p:nvSpPr>
@@ -16549,7 +16404,7 @@
       </p:sp>
       <p:sp>
         <p:nvSpPr>
-          <p:cNvPr id="43" name="TextBox 42"/>
+          <p:cNvPr id="44" name="TextBox 43"/>
           <p:cNvSpPr txBox="1"/>
           <p:nvPr/>
         </p:nvSpPr>
@@ -16583,7 +16438,7 @@
       </p:sp>
       <p:sp>
         <p:nvSpPr>
-          <p:cNvPr id="44" name="TextBox 43"/>
+          <p:cNvPr id="45" name="TextBox 44"/>
           <p:cNvSpPr txBox="1"/>
           <p:nvPr/>
         </p:nvSpPr>
@@ -16610,14 +16465,14 @@
                   <a:srgbClr val="FFFFFF"/>
                 </a:solidFill>
               </a:rPr>
-              <a:t>• Optocouplers required on TRIAC side</a:t>
-            </a:r>
-          </a:p>
-        </p:txBody>
-      </p:sp>
-      <p:sp>
-        <p:nvSpPr>
-          <p:cNvPr id="45" name="TextBox 44"/>
+              <a:t>• Dimmer module has built-in optocouplers</a:t>
+            </a:r>
+          </a:p>
+        </p:txBody>
+      </p:sp>
+      <p:sp>
+        <p:nvSpPr>
+          <p:cNvPr id="46" name="TextBox 45"/>
           <p:cNvSpPr txBox="1"/>
           <p:nvPr/>
         </p:nvSpPr>
@@ -16644,7 +16499,41 @@
                   <a:srgbClr val="FFFFFF"/>
                 </a:solidFill>
               </a:rPr>
-              <a:t>• Fuse the AC circuit (5–10A slow blow)</a:t>
+              <a:t>• Fuse AC input (5–10A slow blow)</a:t>
+            </a:r>
+          </a:p>
+        </p:txBody>
+      </p:sp>
+      <p:sp>
+        <p:nvSpPr>
+          <p:cNvPr id="47" name="TextBox 46"/>
+          <p:cNvSpPr txBox="1"/>
+          <p:nvPr/>
+        </p:nvSpPr>
+        <p:spPr>
+          <a:xfrm>
+            <a:off x="8211312" y="5458204"/>
+            <a:ext cx="3511296" cy="321564"/>
+          </a:xfrm>
+          <a:prstGeom prst="rect">
+            <a:avLst/>
+          </a:prstGeom>
+          <a:noFill/>
+        </p:spPr>
+        <p:txBody>
+          <a:bodyPr wrap="square">
+            <a:spAutoFit/>
+          </a:bodyPr>
+          <a:lstStyle/>
+          <a:p>
+            <a:pPr algn="l"/>
+            <a:r>
+              <a:rPr sz="1400" b="0">
+                <a:solidFill>
+                  <a:srgbClr val="FFFFFF"/>
+                </a:solidFill>
+              </a:rPr>
+              <a:t>• Do AC wiring last — verify logic first</a:t>
             </a:r>
           </a:p>
         </p:txBody>

</xml_diff>

<commit_message>
docs: clarify igniter dimmer purpose — soft-start not variable power
Igniter uses CH2 dimmer to ramp 0→100% over ~1-2s to limit inrush
current on the cold heating element coil. After ramp holds at 100%.
Updated wiring.md, config.h comment, implementation-plan Phase 5,
and PPTX slide 7.

Co-Authored-By: Claude Sonnet 4.6 <noreply@anthropic.com>
</commit_message>
<xml_diff>
--- a/docs/Pellet_Burner_Components.pptx
+++ b/docs/Pellet_Burner_Components.pptx
@@ -12782,7 +12782,7 @@
         <p:spPr>
           <a:xfrm>
             <a:off x="274320" y="749808"/>
-            <a:ext cx="4937760" cy="3902202"/>
+            <a:ext cx="4937760" cy="4204716"/>
           </a:xfrm>
           <a:prstGeom prst="rect">
             <a:avLst/>
@@ -13185,7 +13185,7 @@
                   <a:srgbClr val="FFFFFF"/>
                 </a:solidFill>
               </a:rPr>
-              <a:t>• CH1 (blower): 0–100% fan speed</a:t>
+              <a:t>• CH1 (blower): 0–100% continuously variable fan speed</a:t>
             </a:r>
           </a:p>
         </p:txBody>
@@ -13219,14 +13219,48 @@
                   <a:srgbClr val="FFFFFF"/>
                 </a:solidFill>
               </a:rPr>
-              <a:t>• CH2 (igniter): 0% = off, 100% = full heat</a:t>
-            </a:r>
-          </a:p>
-        </p:txBody>
-      </p:sp>
-      <p:sp>
-        <p:nvSpPr>
-          <p:cNvPr id="20" name="Rectangle 19"/>
+              <a:t>• CH2 (igniter): soft-start ramp 0→100% over ~1–2 s,</a:t>
+            </a:r>
+          </a:p>
+        </p:txBody>
+      </p:sp>
+      <p:sp>
+        <p:nvSpPr>
+          <p:cNvPr id="20" name="TextBox 19"/>
+          <p:cNvSpPr txBox="1"/>
+          <p:nvPr/>
+        </p:nvSpPr>
+        <p:spPr>
+          <a:xfrm>
+            <a:off x="438912" y="4450833"/>
+            <a:ext cx="4608576" cy="302513"/>
+          </a:xfrm>
+          <a:prstGeom prst="rect">
+            <a:avLst/>
+          </a:prstGeom>
+          <a:noFill/>
+        </p:spPr>
+        <p:txBody>
+          <a:bodyPr wrap="square">
+            <a:spAutoFit/>
+          </a:bodyPr>
+          <a:lstStyle/>
+          <a:p>
+            <a:pPr algn="l"/>
+            <a:r>
+              <a:rPr sz="1300" b="0">
+                <a:solidFill>
+                  <a:srgbClr val="FFFFFF"/>
+                </a:solidFill>
+              </a:rPr>
+              <a:t>• then holds at 100% — limits inrush on cold coil</a:t>
+            </a:r>
+          </a:p>
+        </p:txBody>
+      </p:sp>
+      <p:sp>
+        <p:nvSpPr>
+          <p:cNvPr id="21" name="Rectangle 20"/>
           <p:cNvSpPr/>
           <p:nvPr/>
         </p:nvSpPr>
@@ -13269,7 +13303,7 @@
       </p:sp>
       <p:sp>
         <p:nvSpPr>
-          <p:cNvPr id="21" name="TextBox 20"/>
+          <p:cNvPr id="22" name="TextBox 21"/>
           <p:cNvSpPr txBox="1"/>
           <p:nvPr/>
         </p:nvSpPr>
@@ -13303,7 +13337,7 @@
       </p:sp>
       <p:sp>
         <p:nvSpPr>
-          <p:cNvPr id="22" name="TextBox 21"/>
+          <p:cNvPr id="23" name="TextBox 22"/>
           <p:cNvSpPr txBox="1"/>
           <p:nvPr/>
         </p:nvSpPr>
@@ -13337,7 +13371,7 @@
       </p:sp>
       <p:sp>
         <p:nvSpPr>
-          <p:cNvPr id="23" name="TextBox 22"/>
+          <p:cNvPr id="24" name="TextBox 23"/>
           <p:cNvSpPr txBox="1"/>
           <p:nvPr/>
         </p:nvSpPr>
@@ -13371,7 +13405,7 @@
       </p:sp>
       <p:sp>
         <p:nvSpPr>
-          <p:cNvPr id="24" name="TextBox 23"/>
+          <p:cNvPr id="25" name="TextBox 24"/>
           <p:cNvSpPr txBox="1"/>
           <p:nvPr/>
         </p:nvSpPr>
@@ -13405,7 +13439,7 @@
       </p:sp>
       <p:sp>
         <p:nvSpPr>
-          <p:cNvPr id="25" name="TextBox 24"/>
+          <p:cNvPr id="26" name="TextBox 25"/>
           <p:cNvSpPr txBox="1"/>
           <p:nvPr/>
         </p:nvSpPr>
@@ -13439,7 +13473,7 @@
       </p:sp>
       <p:sp>
         <p:nvSpPr>
-          <p:cNvPr id="26" name="TextBox 25"/>
+          <p:cNvPr id="27" name="TextBox 26"/>
           <p:cNvSpPr txBox="1"/>
           <p:nvPr/>
         </p:nvSpPr>
@@ -13466,14 +13500,14 @@
                   <a:srgbClr val="FFFFFF"/>
                 </a:solidFill>
               </a:rPr>
-              <a:t>• DIM2 →  GPIO26  (CH2 — igniter heater)</a:t>
-            </a:r>
-          </a:p>
-        </p:txBody>
-      </p:sp>
-      <p:sp>
-        <p:nvSpPr>
-          <p:cNvPr id="27" name="TextBox 26"/>
+              <a:t>• DIM2 →  GPIO26  (CH2 — igniter soft-start)</a:t>
+            </a:r>
+          </a:p>
+        </p:txBody>
+      </p:sp>
+      <p:sp>
+        <p:nvSpPr>
+          <p:cNvPr id="28" name="TextBox 27"/>
           <p:cNvSpPr txBox="1"/>
           <p:nvPr/>
         </p:nvSpPr>
@@ -13507,7 +13541,7 @@
       </p:sp>
       <p:sp>
         <p:nvSpPr>
-          <p:cNvPr id="28" name="TextBox 27"/>
+          <p:cNvPr id="29" name="TextBox 28"/>
           <p:cNvSpPr txBox="1"/>
           <p:nvPr/>
         </p:nvSpPr>
@@ -13541,7 +13575,7 @@
       </p:sp>
       <p:sp>
         <p:nvSpPr>
-          <p:cNvPr id="29" name="TextBox 28"/>
+          <p:cNvPr id="30" name="TextBox 29"/>
           <p:cNvSpPr txBox="1"/>
           <p:nvPr/>
         </p:nvSpPr>
@@ -13575,7 +13609,7 @@
       </p:sp>
       <p:sp>
         <p:nvSpPr>
-          <p:cNvPr id="30" name="TextBox 29"/>
+          <p:cNvPr id="31" name="TextBox 30"/>
           <p:cNvSpPr txBox="1"/>
           <p:nvPr/>
         </p:nvSpPr>
@@ -13609,7 +13643,7 @@
       </p:sp>
       <p:sp>
         <p:nvSpPr>
-          <p:cNvPr id="31" name="TextBox 30"/>
+          <p:cNvPr id="32" name="TextBox 31"/>
           <p:cNvSpPr txBox="1"/>
           <p:nvPr/>
         </p:nvSpPr>
@@ -13643,7 +13677,7 @@
       </p:sp>
       <p:sp>
         <p:nvSpPr>
-          <p:cNvPr id="32" name="TextBox 31"/>
+          <p:cNvPr id="33" name="TextBox 32"/>
           <p:cNvSpPr txBox="1"/>
           <p:nvPr/>
         </p:nvSpPr>
@@ -13677,7 +13711,7 @@
       </p:sp>
       <p:sp>
         <p:nvSpPr>
-          <p:cNvPr id="33" name="TextBox 32"/>
+          <p:cNvPr id="34" name="TextBox 33"/>
           <p:cNvSpPr txBox="1"/>
           <p:nvPr/>
         </p:nvSpPr>
@@ -13711,7 +13745,7 @@
       </p:sp>
       <p:sp>
         <p:nvSpPr>
-          <p:cNvPr id="34" name="TextBox 33"/>
+          <p:cNvPr id="35" name="TextBox 34"/>
           <p:cNvSpPr txBox="1"/>
           <p:nvPr/>
         </p:nvSpPr>

</xml_diff>